<commit_message>
This is the Alger's Forest Fire project
</commit_message>
<xml_diff>
--- a/FELIX OWUSU-ANSAH PREDICTIVE AND PRESCRIPTIVE ANALYTICS.pptx
+++ b/FELIX OWUSU-ANSAH PREDICTIVE AND PRESCRIPTIVE ANALYTICS.pptx
@@ -5,7 +5,7 @@
     <p:sldMasterId id="2147483678" r:id="rId1"/>
   </p:sldMasterIdLst>
   <p:notesMasterIdLst>
-    <p:notesMasterId r:id="rId11"/>
+    <p:notesMasterId r:id="rId12"/>
   </p:notesMasterIdLst>
   <p:sldIdLst>
     <p:sldId id="256" r:id="rId2"/>
@@ -13,10 +13,11 @@
     <p:sldId id="258" r:id="rId4"/>
     <p:sldId id="259" r:id="rId5"/>
     <p:sldId id="260" r:id="rId6"/>
-    <p:sldId id="261" r:id="rId7"/>
-    <p:sldId id="262" r:id="rId8"/>
-    <p:sldId id="263" r:id="rId9"/>
+    <p:sldId id="262" r:id="rId7"/>
+    <p:sldId id="263" r:id="rId8"/>
+    <p:sldId id="261" r:id="rId9"/>
     <p:sldId id="264" r:id="rId10"/>
+    <p:sldId id="265" r:id="rId11"/>
   </p:sldIdLst>
   <p:sldSz cx="12192000" cy="6858000"/>
   <p:notesSz cx="6858000" cy="9144000"/>
@@ -205,7 +206,7 @@
           <a:p>
             <a:fld id="{D0235172-1D61-4B99-9684-9C05D2D3DD43}" type="datetimeFigureOut">
               <a:rPr lang="en-US" smtClean="0"/>
-              <a:t>4/16/2026</a:t>
+              <a:t>4/17/2026</a:t>
             </a:fld>
             <a:endParaRPr lang="en-US"/>
           </a:p>
@@ -9349,7 +9350,7 @@
           <a:p>
             <a:fld id="{418DFB14-67C6-4843-BD4A-5010E04839EA}" type="datetimeFigureOut">
               <a:rPr lang="en-US" smtClean="0"/>
-              <a:t>4/16/2026</a:t>
+              <a:t>4/17/2026</a:t>
             </a:fld>
             <a:endParaRPr lang="en-US"/>
           </a:p>
@@ -9556,7 +9557,7 @@
           <a:p>
             <a:fld id="{418DFB14-67C6-4843-BD4A-5010E04839EA}" type="datetimeFigureOut">
               <a:rPr lang="en-US" smtClean="0"/>
-              <a:t>4/16/2026</a:t>
+              <a:t>4/17/2026</a:t>
             </a:fld>
             <a:endParaRPr lang="en-US"/>
           </a:p>
@@ -9736,7 +9737,7 @@
           <a:p>
             <a:fld id="{418DFB14-67C6-4843-BD4A-5010E04839EA}" type="datetimeFigureOut">
               <a:rPr lang="en-US" smtClean="0"/>
-              <a:t>4/16/2026</a:t>
+              <a:t>4/17/2026</a:t>
             </a:fld>
             <a:endParaRPr lang="en-US"/>
           </a:p>
@@ -9946,7 +9947,7 @@
           <a:p>
             <a:fld id="{418DFB14-67C6-4843-BD4A-5010E04839EA}" type="datetimeFigureOut">
               <a:rPr lang="en-US" smtClean="0"/>
-              <a:t>4/16/2026</a:t>
+              <a:t>4/17/2026</a:t>
             </a:fld>
             <a:endParaRPr lang="en-US"/>
           </a:p>
@@ -10195,7 +10196,7 @@
           <a:p>
             <a:fld id="{418DFB14-67C6-4843-BD4A-5010E04839EA}" type="datetimeFigureOut">
               <a:rPr lang="en-US" smtClean="0"/>
-              <a:t>4/16/2026</a:t>
+              <a:t>4/17/2026</a:t>
             </a:fld>
             <a:endParaRPr lang="en-US"/>
           </a:p>
@@ -10365,7 +10366,7 @@
           <a:p>
             <a:fld id="{418DFB14-67C6-4843-BD4A-5010E04839EA}" type="datetimeFigureOut">
               <a:rPr lang="en-US" smtClean="0"/>
-              <a:t>4/16/2026</a:t>
+              <a:t>4/17/2026</a:t>
             </a:fld>
             <a:endParaRPr lang="en-US"/>
           </a:p>
@@ -19263,7 +19264,7 @@
           <a:p>
             <a:fld id="{418DFB14-67C6-4843-BD4A-5010E04839EA}" type="datetimeFigureOut">
               <a:rPr lang="en-US" smtClean="0"/>
-              <a:t>4/16/2026</a:t>
+              <a:t>4/17/2026</a:t>
             </a:fld>
             <a:endParaRPr lang="en-US"/>
           </a:p>
@@ -19537,7 +19538,7 @@
           <a:p>
             <a:fld id="{418DFB14-67C6-4843-BD4A-5010E04839EA}" type="datetimeFigureOut">
               <a:rPr lang="en-US" smtClean="0"/>
-              <a:t>4/16/2026</a:t>
+              <a:t>4/17/2026</a:t>
             </a:fld>
             <a:endParaRPr lang="en-US"/>
           </a:p>
@@ -19935,7 +19936,7 @@
           <a:p>
             <a:fld id="{418DFB14-67C6-4843-BD4A-5010E04839EA}" type="datetimeFigureOut">
               <a:rPr lang="en-US" smtClean="0"/>
-              <a:t>4/16/2026</a:t>
+              <a:t>4/17/2026</a:t>
             </a:fld>
             <a:endParaRPr lang="en-US"/>
           </a:p>
@@ -20053,7 +20054,7 @@
           <a:p>
             <a:fld id="{418DFB14-67C6-4843-BD4A-5010E04839EA}" type="datetimeFigureOut">
               <a:rPr lang="en-US" smtClean="0"/>
-              <a:t>4/16/2026</a:t>
+              <a:t>4/17/2026</a:t>
             </a:fld>
             <a:endParaRPr lang="en-US"/>
           </a:p>
@@ -20148,7 +20149,7 @@
           <a:p>
             <a:fld id="{418DFB14-67C6-4843-BD4A-5010E04839EA}" type="datetimeFigureOut">
               <a:rPr lang="en-US" smtClean="0"/>
-              <a:t>4/16/2026</a:t>
+              <a:t>4/17/2026</a:t>
             </a:fld>
             <a:endParaRPr lang="en-US"/>
           </a:p>
@@ -20438,7 +20439,7 @@
           <a:p>
             <a:fld id="{418DFB14-67C6-4843-BD4A-5010E04839EA}" type="datetimeFigureOut">
               <a:rPr lang="en-US" smtClean="0"/>
-              <a:t>4/16/2026</a:t>
+              <a:t>4/17/2026</a:t>
             </a:fld>
             <a:endParaRPr lang="en-US"/>
           </a:p>
@@ -20718,7 +20719,7 @@
           <a:p>
             <a:fld id="{418DFB14-67C6-4843-BD4A-5010E04839EA}" type="datetimeFigureOut">
               <a:rPr lang="en-US" smtClean="0"/>
-              <a:t>4/16/2026</a:t>
+              <a:t>4/17/2026</a:t>
             </a:fld>
             <a:endParaRPr lang="en-US"/>
           </a:p>
@@ -20968,7 +20969,7 @@
           <a:p>
             <a:fld id="{418DFB14-67C6-4843-BD4A-5010E04839EA}" type="datetimeFigureOut">
               <a:rPr lang="en-US" smtClean="0"/>
-              <a:t>4/16/2026</a:t>
+              <a:t>4/17/2026</a:t>
             </a:fld>
             <a:endParaRPr lang="en-US"/>
           </a:p>
@@ -21572,6 +21573,285 @@
 </p:sld>
 </file>
 
+<file path=ppt/slides/slide10.xml><?xml version="1.0" encoding="utf-8"?>
+<p:sld xmlns:a="http://schemas.openxmlformats.org/drawingml/2006/main" xmlns:r="http://schemas.openxmlformats.org/officeDocument/2006/relationships" xmlns:p="http://schemas.openxmlformats.org/presentationml/2006/main">
+  <p:cSld>
+    <p:spTree>
+      <p:nvGrpSpPr>
+        <p:cNvPr id="1" name=""/>
+        <p:cNvGrpSpPr/>
+        <p:nvPr/>
+      </p:nvGrpSpPr>
+      <p:grpSpPr>
+        <a:xfrm>
+          <a:off x="0" y="0"/>
+          <a:ext cx="0" cy="0"/>
+          <a:chOff x="0" y="0"/>
+          <a:chExt cx="0" cy="0"/>
+        </a:xfrm>
+      </p:grpSpPr>
+      <p:sp>
+        <p:nvSpPr>
+          <p:cNvPr id="2" name="Title 1">
+            <a:extLst>
+              <a:ext uri="{FF2B5EF4-FFF2-40B4-BE49-F238E27FC236}">
+                <a16:creationId xmlns:a16="http://schemas.microsoft.com/office/drawing/2014/main" id="{4B52BF82-8C4E-7D40-C7EC-6B0B81F3642A}"/>
+              </a:ext>
+            </a:extLst>
+          </p:cNvPr>
+          <p:cNvSpPr>
+            <a:spLocks noGrp="1"/>
+          </p:cNvSpPr>
+          <p:nvPr>
+            <p:ph type="title"/>
+          </p:nvPr>
+        </p:nvSpPr>
+        <p:spPr>
+          <a:xfrm>
+            <a:off x="881515" y="830510"/>
+            <a:ext cx="10980518" cy="1019430"/>
+          </a:xfrm>
+        </p:spPr>
+        <p:txBody>
+          <a:bodyPr>
+            <a:normAutofit fontScale="90000"/>
+          </a:bodyPr>
+          <a:lstStyle/>
+          <a:p>
+            <a:r>
+              <a:rPr lang="en-US" sz="4400" b="1" dirty="0">
+                <a:latin typeface="Garamond" panose="02020404030301010803" pitchFamily="18" charset="0"/>
+              </a:rPr>
+              <a:t>RECOMMENDATIONS TO THE COUNTRY</a:t>
+            </a:r>
+            <a:endParaRPr lang="en-GH" dirty="0"/>
+          </a:p>
+        </p:txBody>
+      </p:sp>
+      <p:sp>
+        <p:nvSpPr>
+          <p:cNvPr id="5" name="TextBox 4">
+            <a:extLst>
+              <a:ext uri="{FF2B5EF4-FFF2-40B4-BE49-F238E27FC236}">
+                <a16:creationId xmlns:a16="http://schemas.microsoft.com/office/drawing/2014/main" id="{4FFD5153-CA90-7B3F-712B-7AED65BCC88D}"/>
+              </a:ext>
+            </a:extLst>
+          </p:cNvPr>
+          <p:cNvSpPr txBox="1"/>
+          <p:nvPr/>
+        </p:nvSpPr>
+        <p:spPr>
+          <a:xfrm>
+            <a:off x="771787" y="2296272"/>
+            <a:ext cx="5324214" cy="3139321"/>
+          </a:xfrm>
+          <a:prstGeom prst="rect">
+            <a:avLst/>
+          </a:prstGeom>
+          <a:noFill/>
+        </p:spPr>
+        <p:txBody>
+          <a:bodyPr wrap="square" numCol="1">
+            <a:spAutoFit/>
+          </a:bodyPr>
+          <a:lstStyle/>
+          <a:p>
+            <a:pPr lvl="0"/>
+            <a:r>
+              <a:rPr lang="en-US" b="1" dirty="0">
+                <a:latin typeface="Garamond" panose="02020404030301010803" pitchFamily="18" charset="0"/>
+              </a:rPr>
+              <a:t>1. EARLY WARNING SYSTEM</a:t>
+            </a:r>
+            <a:endParaRPr lang="en-GH" dirty="0">
+              <a:latin typeface="Garamond" panose="02020404030301010803" pitchFamily="18" charset="0"/>
+            </a:endParaRPr>
+          </a:p>
+          <a:p>
+            <a:pPr lvl="0"/>
+            <a:r>
+              <a:rPr lang="en-US" dirty="0">
+                <a:latin typeface="Garamond" panose="02020404030301010803" pitchFamily="18" charset="0"/>
+              </a:rPr>
+              <a:t> Deploy the Decision Tree model as a national early warning system. It will alert authorities when fire risk is high.</a:t>
+            </a:r>
+          </a:p>
+          <a:p>
+            <a:pPr lvl="0"/>
+            <a:endParaRPr lang="en-GH" dirty="0">
+              <a:latin typeface="Garamond" panose="02020404030301010803" pitchFamily="18" charset="0"/>
+            </a:endParaRPr>
+          </a:p>
+          <a:p>
+            <a:pPr lvl="0"/>
+            <a:r>
+              <a:rPr lang="en-US" b="1" dirty="0">
+                <a:latin typeface="Garamond" panose="02020404030301010803" pitchFamily="18" charset="0"/>
+              </a:rPr>
+              <a:t>2. RESOURCE ALLOCATION</a:t>
+            </a:r>
+            <a:endParaRPr lang="en-GH" dirty="0">
+              <a:latin typeface="Garamond" panose="02020404030301010803" pitchFamily="18" charset="0"/>
+            </a:endParaRPr>
+          </a:p>
+          <a:p>
+            <a:pPr lvl="0"/>
+            <a:r>
+              <a:rPr lang="en-US" dirty="0">
+                <a:latin typeface="Garamond" panose="02020404030301010803" pitchFamily="18" charset="0"/>
+              </a:rPr>
+              <a:t>   Concentrate firefighting resources on days with:</a:t>
+            </a:r>
+            <a:endParaRPr lang="en-GH" dirty="0">
+              <a:latin typeface="Garamond" panose="02020404030301010803" pitchFamily="18" charset="0"/>
+            </a:endParaRPr>
+          </a:p>
+          <a:p>
+            <a:pPr lvl="0"/>
+            <a:r>
+              <a:rPr lang="en-US" dirty="0">
+                <a:latin typeface="Garamond" panose="02020404030301010803" pitchFamily="18" charset="0"/>
+              </a:rPr>
+              <a:t>   Wind speeds above 5 km/h</a:t>
+            </a:r>
+            <a:endParaRPr lang="en-GH" dirty="0">
+              <a:latin typeface="Garamond" panose="02020404030301010803" pitchFamily="18" charset="0"/>
+            </a:endParaRPr>
+          </a:p>
+          <a:p>
+            <a:pPr lvl="0"/>
+            <a:r>
+              <a:rPr lang="en-US" dirty="0">
+                <a:latin typeface="Garamond" panose="02020404030301010803" pitchFamily="18" charset="0"/>
+              </a:rPr>
+              <a:t>   Temperatures above 25°C</a:t>
+            </a:r>
+            <a:endParaRPr lang="en-GH" dirty="0">
+              <a:latin typeface="Garamond" panose="02020404030301010803" pitchFamily="18" charset="0"/>
+            </a:endParaRPr>
+          </a:p>
+          <a:p>
+            <a:pPr lvl="0"/>
+            <a:r>
+              <a:rPr lang="en-US" dirty="0">
+                <a:latin typeface="Garamond" panose="02020404030301010803" pitchFamily="18" charset="0"/>
+              </a:rPr>
+              <a:t>   Low rainfall in the preceding week</a:t>
+            </a:r>
+            <a:endParaRPr lang="en-GH" dirty="0">
+              <a:latin typeface="Garamond" panose="02020404030301010803" pitchFamily="18" charset="0"/>
+            </a:endParaRPr>
+          </a:p>
+          <a:p>
+            <a:pPr marL="342900" lvl="0" indent="-342900">
+              <a:spcAft>
+                <a:spcPts val="800"/>
+              </a:spcAft>
+              <a:buFont typeface="Tw Cen MT" panose="020B0602020104020603" pitchFamily="34" charset="0"/>
+              <a:buChar char=" "/>
+              <a:tabLst>
+                <a:tab pos="457200" algn="l"/>
+              </a:tabLst>
+            </a:pPr>
+            <a:endParaRPr lang="en-GH" sz="1800" kern="100" dirty="0">
+              <a:effectLst/>
+              <a:latin typeface="Garamond" panose="02020404030301010803" pitchFamily="18" charset="0"/>
+              <a:ea typeface="DengXian" panose="02010600030101010101" pitchFamily="2" charset="-122"/>
+              <a:cs typeface="Times New Roman" panose="02020603050405020304" pitchFamily="18" charset="0"/>
+            </a:endParaRPr>
+          </a:p>
+        </p:txBody>
+      </p:sp>
+      <p:sp>
+        <p:nvSpPr>
+          <p:cNvPr id="9" name="TextBox 8">
+            <a:extLst>
+              <a:ext uri="{FF2B5EF4-FFF2-40B4-BE49-F238E27FC236}">
+                <a16:creationId xmlns:a16="http://schemas.microsoft.com/office/drawing/2014/main" id="{A312E4D7-7AA7-5B0F-84F9-7D8D5C9605D8}"/>
+              </a:ext>
+            </a:extLst>
+          </p:cNvPr>
+          <p:cNvSpPr txBox="1"/>
+          <p:nvPr/>
+        </p:nvSpPr>
+        <p:spPr>
+          <a:xfrm>
+            <a:off x="6371774" y="2296272"/>
+            <a:ext cx="5167618" cy="2031325"/>
+          </a:xfrm>
+          <a:prstGeom prst="rect">
+            <a:avLst/>
+          </a:prstGeom>
+          <a:noFill/>
+        </p:spPr>
+        <p:txBody>
+          <a:bodyPr wrap="square">
+            <a:spAutoFit/>
+          </a:bodyPr>
+          <a:lstStyle/>
+          <a:p>
+            <a:pPr algn="just"/>
+            <a:r>
+              <a:rPr lang="en-US" b="1" dirty="0">
+                <a:latin typeface="Garamond" panose="02020404030301010803" pitchFamily="18" charset="0"/>
+              </a:rPr>
+              <a:t>3. PUBLIC AWARENESS</a:t>
+            </a:r>
+          </a:p>
+          <a:p>
+            <a:pPr algn="just"/>
+            <a:r>
+              <a:rPr lang="en-US" dirty="0">
+                <a:latin typeface="Garamond" panose="02020404030301010803" pitchFamily="18" charset="0"/>
+              </a:rPr>
+              <a:t>Issue public warnings when the model predicts high fire risk, especially during dry, windy, and hot conditions.</a:t>
+            </a:r>
+          </a:p>
+          <a:p>
+            <a:pPr algn="just"/>
+            <a:endParaRPr lang="en-GH" dirty="0">
+              <a:latin typeface="Garamond" panose="02020404030301010803" pitchFamily="18" charset="0"/>
+            </a:endParaRPr>
+          </a:p>
+          <a:p>
+            <a:pPr algn="just"/>
+            <a:r>
+              <a:rPr lang="en-US" b="1" dirty="0">
+                <a:latin typeface="Garamond" panose="02020404030301010803" pitchFamily="18" charset="0"/>
+              </a:rPr>
+              <a:t>4. PREVENTIVE ACTIONS</a:t>
+            </a:r>
+            <a:endParaRPr lang="en-GH" b="1" dirty="0">
+              <a:latin typeface="Garamond" panose="02020404030301010803" pitchFamily="18" charset="0"/>
+            </a:endParaRPr>
+          </a:p>
+          <a:p>
+            <a:pPr algn="just"/>
+            <a:r>
+              <a:rPr lang="en-US" dirty="0">
+                <a:latin typeface="Garamond" panose="02020404030301010803" pitchFamily="18" charset="0"/>
+              </a:rPr>
+              <a:t>Implement controlled burns and firebreaks before high-risk periods identified by the model.</a:t>
+            </a:r>
+            <a:endParaRPr lang="en-GH" dirty="0">
+              <a:latin typeface="Garamond" panose="02020404030301010803" pitchFamily="18" charset="0"/>
+            </a:endParaRPr>
+          </a:p>
+        </p:txBody>
+      </p:sp>
+    </p:spTree>
+    <p:extLst>
+      <p:ext uri="{BB962C8B-B14F-4D97-AF65-F5344CB8AC3E}">
+        <p14:creationId xmlns:p14="http://schemas.microsoft.com/office/powerpoint/2010/main" val="2394967737"/>
+      </p:ext>
+    </p:extLst>
+  </p:cSld>
+  <p:clrMapOvr>
+    <a:masterClrMapping/>
+  </p:clrMapOvr>
+</p:sld>
+</file>
+
 <file path=ppt/slides/slide2.xml><?xml version="1.0" encoding="utf-8"?>
 <p:sld xmlns:a="http://schemas.openxmlformats.org/drawingml/2006/main" xmlns:r="http://schemas.openxmlformats.org/officeDocument/2006/relationships" xmlns:p="http://schemas.openxmlformats.org/presentationml/2006/main">
   <p:cSld>
@@ -21627,7 +21907,7 @@
                 <a:ea typeface="Calibri" panose="020F0502020204030204" pitchFamily="34" charset="0"/>
                 <a:cs typeface="Times New Roman" panose="02020603050405020304" pitchFamily="18" charset="0"/>
               </a:rPr>
-              <a:t>FOREST FIRES PROJECT</a:t>
+              <a:t>ALGERIA FOREST FIRES PROJECT</a:t>
             </a:r>
             <a:br>
               <a:rPr lang="en-US" sz="4800" kern="100" dirty="0">
@@ -21661,8 +21941,8 @@
         </p:nvSpPr>
         <p:spPr>
           <a:xfrm>
-            <a:off x="768440" y="1716946"/>
-            <a:ext cx="10363826" cy="3424107"/>
+            <a:off x="768439" y="1716946"/>
+            <a:ext cx="11127149" cy="3424107"/>
           </a:xfrm>
         </p:spPr>
         <p:txBody>
@@ -21709,381 +21989,6 @@
           </a:p>
         </p:txBody>
       </p:sp>
-      <p:graphicFrame>
-        <p:nvGraphicFramePr>
-          <p:cNvPr id="4" name="Table 3">
-            <a:extLst>
-              <a:ext uri="{FF2B5EF4-FFF2-40B4-BE49-F238E27FC236}">
-                <a16:creationId xmlns:a16="http://schemas.microsoft.com/office/drawing/2014/main" id="{847BE394-C36C-5633-82FF-4D6CDF28A15A}"/>
-              </a:ext>
-            </a:extLst>
-          </p:cNvPr>
-          <p:cNvGraphicFramePr>
-            <a:graphicFrameLocks noGrp="1"/>
-          </p:cNvGraphicFramePr>
-          <p:nvPr>
-            <p:extLst>
-              <p:ext uri="{D42A27DB-BD31-4B8C-83A1-F6EECF244321}">
-                <p14:modId xmlns:p14="http://schemas.microsoft.com/office/powerpoint/2010/main" val="3063617719"/>
-              </p:ext>
-            </p:extLst>
-          </p:nvPr>
-        </p:nvGraphicFramePr>
-        <p:xfrm>
-          <a:off x="5406264" y="3766144"/>
-          <a:ext cx="6017296" cy="2892372"/>
-        </p:xfrm>
-        <a:graphic>
-          <a:graphicData uri="http://schemas.openxmlformats.org/drawingml/2006/table">
-            <a:tbl>
-              <a:tblPr firstRow="1" bandRow="1">
-                <a:tableStyleId>{5C22544A-7EE6-4342-B048-85BDC9FD1C3A}</a:tableStyleId>
-              </a:tblPr>
-              <a:tblGrid>
-                <a:gridCol w="3008648">
-                  <a:extLst>
-                    <a:ext uri="{9D8B030D-6E8A-4147-A177-3AD203B41FA5}">
-                      <a16:colId xmlns:a16="http://schemas.microsoft.com/office/drawing/2014/main" val="3601228657"/>
-                    </a:ext>
-                  </a:extLst>
-                </a:gridCol>
-                <a:gridCol w="3008648">
-                  <a:extLst>
-                    <a:ext uri="{9D8B030D-6E8A-4147-A177-3AD203B41FA5}">
-                      <a16:colId xmlns:a16="http://schemas.microsoft.com/office/drawing/2014/main" val="2477199336"/>
-                    </a:ext>
-                  </a:extLst>
-                </a:gridCol>
-              </a:tblGrid>
-              <a:tr h="375382">
-                <a:tc>
-                  <a:txBody>
-                    <a:bodyPr/>
-                    <a:lstStyle/>
-                    <a:p>
-                      <a:r>
-                        <a:rPr lang="en-US" dirty="0"/>
-                        <a:t>Data Features</a:t>
-                      </a:r>
-                    </a:p>
-                  </a:txBody>
-                  <a:tcPr/>
-                </a:tc>
-                <a:tc>
-                  <a:txBody>
-                    <a:bodyPr/>
-                    <a:lstStyle/>
-                    <a:p>
-                      <a:r>
-                        <a:rPr lang="en-US" dirty="0"/>
-                        <a:t>FWI Components</a:t>
-                      </a:r>
-                    </a:p>
-                  </a:txBody>
-                  <a:tcPr/>
-                </a:tc>
-                <a:extLst>
-                  <a:ext uri="{0D108BD9-81ED-4DB2-BD59-A6C34878D82A}">
-                    <a16:rowId xmlns:a16="http://schemas.microsoft.com/office/drawing/2014/main" val="3751166053"/>
-                  </a:ext>
-                </a:extLst>
-              </a:tr>
-              <a:tr h="436367">
-                <a:tc>
-                  <a:txBody>
-                    <a:bodyPr/>
-                    <a:lstStyle/>
-                    <a:p>
-                      <a:r>
-                        <a:rPr lang="en-US" sz="1800" kern="1200" dirty="0">
-                          <a:solidFill>
-                            <a:schemeClr val="dk1"/>
-                          </a:solidFill>
-                          <a:effectLst/>
-                          <a:latin typeface="+mn-lt"/>
-                          <a:ea typeface="+mn-ea"/>
-                          <a:cs typeface="+mn-cs"/>
-                        </a:rPr>
-                        <a:t>Month</a:t>
-                      </a:r>
-                    </a:p>
-                  </a:txBody>
-                  <a:tcPr/>
-                </a:tc>
-                <a:tc>
-                  <a:txBody>
-                    <a:bodyPr/>
-                    <a:lstStyle/>
-                    <a:p>
-                      <a:r>
-                        <a:rPr lang="en-US" dirty="0"/>
-                        <a:t>Fine Fuel Moisture Code (FFMC)</a:t>
-                      </a:r>
-                    </a:p>
-                  </a:txBody>
-                  <a:tcPr/>
-                </a:tc>
-                <a:extLst>
-                  <a:ext uri="{0D108BD9-81ED-4DB2-BD59-A6C34878D82A}">
-                    <a16:rowId xmlns:a16="http://schemas.microsoft.com/office/drawing/2014/main" val="1306772065"/>
-                  </a:ext>
-                </a:extLst>
-              </a:tr>
-              <a:tr h="375382">
-                <a:tc>
-                  <a:txBody>
-                    <a:bodyPr/>
-                    <a:lstStyle/>
-                    <a:p>
-                      <a:r>
-                        <a:rPr lang="en-US" sz="1800" kern="1200" dirty="0">
-                          <a:solidFill>
-                            <a:schemeClr val="dk1"/>
-                          </a:solidFill>
-                          <a:effectLst/>
-                          <a:latin typeface="+mn-lt"/>
-                          <a:ea typeface="+mn-ea"/>
-                          <a:cs typeface="+mn-cs"/>
-                        </a:rPr>
-                        <a:t>Day</a:t>
-                      </a:r>
-                    </a:p>
-                  </a:txBody>
-                  <a:tcPr/>
-                </a:tc>
-                <a:tc>
-                  <a:txBody>
-                    <a:bodyPr/>
-                    <a:lstStyle/>
-                    <a:p>
-                      <a:r>
-                        <a:rPr lang="en-US" dirty="0"/>
-                        <a:t>Duff Moisture Code (DMC)</a:t>
-                      </a:r>
-                    </a:p>
-                  </a:txBody>
-                  <a:tcPr/>
-                </a:tc>
-                <a:extLst>
-                  <a:ext uri="{0D108BD9-81ED-4DB2-BD59-A6C34878D82A}">
-                    <a16:rowId xmlns:a16="http://schemas.microsoft.com/office/drawing/2014/main" val="2944376142"/>
-                  </a:ext>
-                </a:extLst>
-              </a:tr>
-              <a:tr h="375382">
-                <a:tc>
-                  <a:txBody>
-                    <a:bodyPr/>
-                    <a:lstStyle/>
-                    <a:p>
-                      <a:r>
-                        <a:rPr lang="en-US" sz="1800" kern="1200" dirty="0">
-                          <a:solidFill>
-                            <a:schemeClr val="dk1"/>
-                          </a:solidFill>
-                          <a:effectLst/>
-                          <a:latin typeface="+mn-lt"/>
-                          <a:ea typeface="+mn-ea"/>
-                          <a:cs typeface="+mn-cs"/>
-                        </a:rPr>
-                        <a:t>Temp</a:t>
-                      </a:r>
-                    </a:p>
-                  </a:txBody>
-                  <a:tcPr/>
-                </a:tc>
-                <a:tc>
-                  <a:txBody>
-                    <a:bodyPr/>
-                    <a:lstStyle/>
-                    <a:p>
-                      <a:r>
-                        <a:rPr lang="en-US" dirty="0"/>
-                        <a:t>Drought Code (DC)</a:t>
-                      </a:r>
-                    </a:p>
-                  </a:txBody>
-                  <a:tcPr/>
-                </a:tc>
-                <a:extLst>
-                  <a:ext uri="{0D108BD9-81ED-4DB2-BD59-A6C34878D82A}">
-                    <a16:rowId xmlns:a16="http://schemas.microsoft.com/office/drawing/2014/main" val="1823862863"/>
-                  </a:ext>
-                </a:extLst>
-              </a:tr>
-              <a:tr h="375382">
-                <a:tc>
-                  <a:txBody>
-                    <a:bodyPr/>
-                    <a:lstStyle/>
-                    <a:p>
-                      <a:r>
-                        <a:rPr lang="en-US" sz="1800" kern="1200" dirty="0">
-                          <a:solidFill>
-                            <a:schemeClr val="dk1"/>
-                          </a:solidFill>
-                          <a:effectLst/>
-                          <a:latin typeface="+mn-lt"/>
-                          <a:ea typeface="+mn-ea"/>
-                          <a:cs typeface="+mn-cs"/>
-                        </a:rPr>
-                        <a:t>RH (Relative Humidity)</a:t>
-                      </a:r>
-                    </a:p>
-                  </a:txBody>
-                  <a:tcPr/>
-                </a:tc>
-                <a:tc>
-                  <a:txBody>
-                    <a:bodyPr/>
-                    <a:lstStyle/>
-                    <a:p>
-                      <a:r>
-                        <a:rPr lang="en-US" dirty="0"/>
-                        <a:t>Initial Spread Index (ISI)</a:t>
-                      </a:r>
-                    </a:p>
-                  </a:txBody>
-                  <a:tcPr/>
-                </a:tc>
-                <a:extLst>
-                  <a:ext uri="{0D108BD9-81ED-4DB2-BD59-A6C34878D82A}">
-                    <a16:rowId xmlns:a16="http://schemas.microsoft.com/office/drawing/2014/main" val="162324275"/>
-                  </a:ext>
-                </a:extLst>
-              </a:tr>
-              <a:tr h="375382">
-                <a:tc>
-                  <a:txBody>
-                    <a:bodyPr/>
-                    <a:lstStyle/>
-                    <a:p>
-                      <a:r>
-                        <a:rPr lang="en-US" sz="1800" kern="1200" dirty="0" err="1">
-                          <a:solidFill>
-                            <a:schemeClr val="dk1"/>
-                          </a:solidFill>
-                          <a:effectLst/>
-                          <a:latin typeface="+mn-lt"/>
-                          <a:ea typeface="+mn-ea"/>
-                          <a:cs typeface="+mn-cs"/>
-                        </a:rPr>
-                        <a:t>Ws</a:t>
-                      </a:r>
-                      <a:r>
-                        <a:rPr lang="en-US" sz="1800" kern="1200" dirty="0">
-                          <a:solidFill>
-                            <a:schemeClr val="dk1"/>
-                          </a:solidFill>
-                          <a:effectLst/>
-                          <a:latin typeface="+mn-lt"/>
-                          <a:ea typeface="+mn-ea"/>
-                          <a:cs typeface="+mn-cs"/>
-                        </a:rPr>
-                        <a:t> (Wind Speed)</a:t>
-                      </a:r>
-                    </a:p>
-                  </a:txBody>
-                  <a:tcPr/>
-                </a:tc>
-                <a:tc>
-                  <a:txBody>
-                    <a:bodyPr/>
-                    <a:lstStyle/>
-                    <a:p>
-                      <a:r>
-                        <a:rPr lang="en-US" dirty="0"/>
-                        <a:t>Buildup Index (BUI)</a:t>
-                      </a:r>
-                    </a:p>
-                  </a:txBody>
-                  <a:tcPr/>
-                </a:tc>
-                <a:extLst>
-                  <a:ext uri="{0D108BD9-81ED-4DB2-BD59-A6C34878D82A}">
-                    <a16:rowId xmlns:a16="http://schemas.microsoft.com/office/drawing/2014/main" val="3378923544"/>
-                  </a:ext>
-                </a:extLst>
-              </a:tr>
-              <a:tr h="375382">
-                <a:tc>
-                  <a:txBody>
-                    <a:bodyPr/>
-                    <a:lstStyle/>
-                    <a:p>
-                      <a:pPr marL="0" marR="0" lvl="0" indent="0" algn="l" defTabSz="914400" rtl="0" eaLnBrk="1" fontAlgn="auto" latinLnBrk="0" hangingPunct="1">
-                        <a:lnSpc>
-                          <a:spcPct val="100000"/>
-                        </a:lnSpc>
-                        <a:spcBef>
-                          <a:spcPts val="0"/>
-                        </a:spcBef>
-                        <a:spcAft>
-                          <a:spcPts val="0"/>
-                        </a:spcAft>
-                        <a:buClrTx/>
-                        <a:buSzTx/>
-                        <a:buFontTx/>
-                        <a:buNone/>
-                        <a:tabLst/>
-                        <a:defRPr/>
-                      </a:pPr>
-                      <a:r>
-                        <a:rPr lang="en-US" sz="1800" kern="1200" dirty="0">
-                          <a:solidFill>
-                            <a:schemeClr val="dk1"/>
-                          </a:solidFill>
-                          <a:effectLst/>
-                          <a:latin typeface="+mn-lt"/>
-                          <a:ea typeface="+mn-ea"/>
-                          <a:cs typeface="+mn-cs"/>
-                        </a:rPr>
-                        <a:t>Rain</a:t>
-                      </a:r>
-                    </a:p>
-                  </a:txBody>
-                  <a:tcPr/>
-                </a:tc>
-                <a:tc>
-                  <a:txBody>
-                    <a:bodyPr/>
-                    <a:lstStyle/>
-                    <a:p>
-                      <a:pPr marL="0" marR="0" lvl="0" indent="0" algn="l" defTabSz="914400" rtl="0" eaLnBrk="1" fontAlgn="auto" latinLnBrk="0" hangingPunct="1">
-                        <a:lnSpc>
-                          <a:spcPct val="100000"/>
-                        </a:lnSpc>
-                        <a:spcBef>
-                          <a:spcPts val="0"/>
-                        </a:spcBef>
-                        <a:spcAft>
-                          <a:spcPts val="0"/>
-                        </a:spcAft>
-                        <a:buClrTx/>
-                        <a:buSzTx/>
-                        <a:buFontTx/>
-                        <a:buNone/>
-                        <a:tabLst/>
-                        <a:defRPr/>
-                      </a:pPr>
-                      <a:r>
-                        <a:rPr lang="en-US" dirty="0"/>
-                        <a:t>Fire Weather Index (FWI)</a:t>
-                      </a:r>
-                    </a:p>
-                  </a:txBody>
-                  <a:tcPr/>
-                </a:tc>
-                <a:extLst>
-                  <a:ext uri="{0D108BD9-81ED-4DB2-BD59-A6C34878D82A}">
-                    <a16:rowId xmlns:a16="http://schemas.microsoft.com/office/drawing/2014/main" val="1411840329"/>
-                  </a:ext>
-                </a:extLst>
-              </a:tr>
-            </a:tbl>
-          </a:graphicData>
-        </a:graphic>
-      </p:graphicFrame>
       <p:sp>
         <p:nvSpPr>
           <p:cNvPr id="6" name="TextBox 5">
@@ -22098,8 +22003,8 @@
         </p:nvSpPr>
         <p:spPr>
           <a:xfrm>
-            <a:off x="537692" y="3766144"/>
-            <a:ext cx="4613857" cy="2585323"/>
+            <a:off x="546081" y="3533572"/>
+            <a:ext cx="4613857" cy="2739211"/>
           </a:xfrm>
           <a:prstGeom prst="rect">
             <a:avLst/>
@@ -22114,7 +22019,7 @@
           <a:p>
             <a:pPr algn="ctr"/>
             <a:r>
-              <a:rPr lang="en-US" b="1" dirty="0">
+              <a:rPr lang="en-US" sz="2800" b="1" dirty="0">
                 <a:latin typeface="Garamond" panose="02020404030301010803" pitchFamily="18" charset="0"/>
               </a:rPr>
               <a:t>Outcome</a:t>
@@ -22135,11 +22040,434 @@
               <a:rPr lang="en-US" dirty="0">
                 <a:latin typeface="Garamond" panose="02020404030301010803" pitchFamily="18" charset="0"/>
               </a:rPr>
-              <a:t>Not Fire: Indicates the absence of a forest fire. These features and indices help in building predictive models to assess and forecast the likelihood of forest fires. The models can analyze patterns and correlations within the data to predict fire occurrence, aiding in effective fire management and prevention strategies.</a:t>
+              <a:t>No Fire: Indicates the absence of a forest fire. These features and indices help in building predictive models to assess and forecast the likelihood of forest fires. The models can analyze patterns and correlations within the data to predict fire occurrence, aiding in effective fire management and prevention strategies.</a:t>
             </a:r>
           </a:p>
         </p:txBody>
       </p:sp>
+      <p:graphicFrame>
+        <p:nvGraphicFramePr>
+          <p:cNvPr id="5" name="Table 4">
+            <a:extLst>
+              <a:ext uri="{FF2B5EF4-FFF2-40B4-BE49-F238E27FC236}">
+                <a16:creationId xmlns:a16="http://schemas.microsoft.com/office/drawing/2014/main" id="{2E620A80-5D83-D974-9551-6E59B55CEC84}"/>
+              </a:ext>
+            </a:extLst>
+          </p:cNvPr>
+          <p:cNvGraphicFramePr>
+            <a:graphicFrameLocks noGrp="1"/>
+          </p:cNvGraphicFramePr>
+          <p:nvPr>
+            <p:extLst>
+              <p:ext uri="{D42A27DB-BD31-4B8C-83A1-F6EECF244321}">
+                <p14:modId xmlns:p14="http://schemas.microsoft.com/office/powerpoint/2010/main" val="2600557658"/>
+              </p:ext>
+            </p:extLst>
+          </p:nvPr>
+        </p:nvGraphicFramePr>
+        <p:xfrm>
+          <a:off x="5771627" y="3428999"/>
+          <a:ext cx="6249798" cy="2590404"/>
+        </p:xfrm>
+        <a:graphic>
+          <a:graphicData uri="http://schemas.openxmlformats.org/drawingml/2006/table">
+            <a:tbl>
+              <a:tblPr>
+                <a:tableStyleId>{5C22544A-7EE6-4342-B048-85BDC9FD1C3A}</a:tableStyleId>
+              </a:tblPr>
+              <a:tblGrid>
+                <a:gridCol w="2973205">
+                  <a:extLst>
+                    <a:ext uri="{9D8B030D-6E8A-4147-A177-3AD203B41FA5}">
+                      <a16:colId xmlns:a16="http://schemas.microsoft.com/office/drawing/2014/main" val="2131627933"/>
+                    </a:ext>
+                  </a:extLst>
+                </a:gridCol>
+                <a:gridCol w="3276593">
+                  <a:extLst>
+                    <a:ext uri="{9D8B030D-6E8A-4147-A177-3AD203B41FA5}">
+                      <a16:colId xmlns:a16="http://schemas.microsoft.com/office/drawing/2014/main" val="2812234862"/>
+                    </a:ext>
+                  </a:extLst>
+                </a:gridCol>
+              </a:tblGrid>
+              <a:tr h="431734">
+                <a:tc>
+                  <a:txBody>
+                    <a:bodyPr/>
+                    <a:lstStyle/>
+                    <a:p>
+                      <a:pPr algn="l" fontAlgn="b">
+                        <a:buNone/>
+                      </a:pPr>
+                      <a:r>
+                        <a:rPr lang="en-US" sz="2400" b="1" u="none" strike="noStrike">
+                          <a:effectLst/>
+                          <a:latin typeface="Garamond" panose="02020404030301010803" pitchFamily="18" charset="0"/>
+                        </a:rPr>
+                        <a:t>Data Features</a:t>
+                      </a:r>
+                      <a:endParaRPr lang="en-US" sz="2400" b="1" i="0" u="none" strike="noStrike">
+                        <a:solidFill>
+                          <a:srgbClr val="FFFFFF"/>
+                        </a:solidFill>
+                        <a:effectLst/>
+                        <a:latin typeface="Garamond" panose="02020404030301010803" pitchFamily="18" charset="0"/>
+                      </a:endParaRPr>
+                    </a:p>
+                  </a:txBody>
+                  <a:tcPr marL="6350" marR="6350" marT="6350" marB="0" anchor="b"/>
+                </a:tc>
+                <a:tc>
+                  <a:txBody>
+                    <a:bodyPr/>
+                    <a:lstStyle/>
+                    <a:p>
+                      <a:pPr algn="l" fontAlgn="b">
+                        <a:buNone/>
+                      </a:pPr>
+                      <a:r>
+                        <a:rPr lang="en-US" sz="2400" b="1" u="none" strike="noStrike" dirty="0">
+                          <a:effectLst/>
+                          <a:latin typeface="Garamond" panose="02020404030301010803" pitchFamily="18" charset="0"/>
+                        </a:rPr>
+                        <a:t>FWI Components</a:t>
+                      </a:r>
+                      <a:endParaRPr lang="en-US" sz="2400" b="1" i="0" u="none" strike="noStrike" dirty="0">
+                        <a:solidFill>
+                          <a:srgbClr val="FFFFFF"/>
+                        </a:solidFill>
+                        <a:effectLst/>
+                        <a:latin typeface="Garamond" panose="02020404030301010803" pitchFamily="18" charset="0"/>
+                      </a:endParaRPr>
+                    </a:p>
+                  </a:txBody>
+                  <a:tcPr marL="6350" marR="6350" marT="6350" marB="0" anchor="b"/>
+                </a:tc>
+                <a:extLst>
+                  <a:ext uri="{0D108BD9-81ED-4DB2-BD59-A6C34878D82A}">
+                    <a16:rowId xmlns:a16="http://schemas.microsoft.com/office/drawing/2014/main" val="3652787857"/>
+                  </a:ext>
+                </a:extLst>
+              </a:tr>
+              <a:tr h="431734">
+                <a:tc>
+                  <a:txBody>
+                    <a:bodyPr/>
+                    <a:lstStyle/>
+                    <a:p>
+                      <a:pPr algn="l" fontAlgn="b">
+                        <a:buNone/>
+                      </a:pPr>
+                      <a:r>
+                        <a:rPr lang="en-US" sz="2000" u="none" strike="noStrike">
+                          <a:effectLst/>
+                        </a:rPr>
+                        <a:t>Month</a:t>
+                      </a:r>
+                      <a:endParaRPr lang="en-US" sz="2000" b="0" i="0" u="none" strike="noStrike">
+                        <a:solidFill>
+                          <a:srgbClr val="000000"/>
+                        </a:solidFill>
+                        <a:effectLst/>
+                        <a:latin typeface="Calibri" panose="020F0502020204030204" pitchFamily="34" charset="0"/>
+                      </a:endParaRPr>
+                    </a:p>
+                  </a:txBody>
+                  <a:tcPr marL="6350" marR="6350" marT="6350" marB="0" anchor="b">
+                    <a:solidFill>
+                      <a:schemeClr val="bg1"/>
+                    </a:solidFill>
+                  </a:tcPr>
+                </a:tc>
+                <a:tc>
+                  <a:txBody>
+                    <a:bodyPr/>
+                    <a:lstStyle/>
+                    <a:p>
+                      <a:pPr algn="l" fontAlgn="b">
+                        <a:buNone/>
+                      </a:pPr>
+                      <a:r>
+                        <a:rPr lang="en-US" sz="2000" u="none" strike="noStrike" dirty="0">
+                          <a:effectLst/>
+                        </a:rPr>
+                        <a:t>Fine Fuel Moisture Code (FFMC)</a:t>
+                      </a:r>
+                      <a:endParaRPr lang="en-US" sz="2000" b="0" i="0" u="none" strike="noStrike" dirty="0">
+                        <a:solidFill>
+                          <a:srgbClr val="000000"/>
+                        </a:solidFill>
+                        <a:effectLst/>
+                        <a:latin typeface="Calibri" panose="020F0502020204030204" pitchFamily="34" charset="0"/>
+                      </a:endParaRPr>
+                    </a:p>
+                  </a:txBody>
+                  <a:tcPr marL="6350" marR="6350" marT="6350" marB="0" anchor="b">
+                    <a:solidFill>
+                      <a:schemeClr val="bg1"/>
+                    </a:solidFill>
+                  </a:tcPr>
+                </a:tc>
+                <a:extLst>
+                  <a:ext uri="{0D108BD9-81ED-4DB2-BD59-A6C34878D82A}">
+                    <a16:rowId xmlns:a16="http://schemas.microsoft.com/office/drawing/2014/main" val="2192275531"/>
+                  </a:ext>
+                </a:extLst>
+              </a:tr>
+              <a:tr h="431734">
+                <a:tc>
+                  <a:txBody>
+                    <a:bodyPr/>
+                    <a:lstStyle/>
+                    <a:p>
+                      <a:pPr algn="l" fontAlgn="b">
+                        <a:buNone/>
+                      </a:pPr>
+                      <a:r>
+                        <a:rPr lang="en-US" sz="2000" u="none" strike="noStrike" dirty="0">
+                          <a:effectLst/>
+                        </a:rPr>
+                        <a:t>Day</a:t>
+                      </a:r>
+                      <a:endParaRPr lang="en-US" sz="2000" b="0" i="0" u="none" strike="noStrike" dirty="0">
+                        <a:solidFill>
+                          <a:srgbClr val="000000"/>
+                        </a:solidFill>
+                        <a:effectLst/>
+                        <a:latin typeface="Calibri" panose="020F0502020204030204" pitchFamily="34" charset="0"/>
+                      </a:endParaRPr>
+                    </a:p>
+                  </a:txBody>
+                  <a:tcPr marL="6350" marR="6350" marT="6350" marB="0" anchor="b"/>
+                </a:tc>
+                <a:tc>
+                  <a:txBody>
+                    <a:bodyPr/>
+                    <a:lstStyle/>
+                    <a:p>
+                      <a:pPr algn="l" fontAlgn="b">
+                        <a:buNone/>
+                      </a:pPr>
+                      <a:r>
+                        <a:rPr lang="en-US" sz="2000" u="none" strike="noStrike" dirty="0">
+                          <a:effectLst/>
+                        </a:rPr>
+                        <a:t>Duff Moisture Code (DMC)</a:t>
+                      </a:r>
+                      <a:endParaRPr lang="en-US" sz="2000" b="0" i="0" u="none" strike="noStrike" dirty="0">
+                        <a:solidFill>
+                          <a:srgbClr val="000000"/>
+                        </a:solidFill>
+                        <a:effectLst/>
+                        <a:latin typeface="Calibri" panose="020F0502020204030204" pitchFamily="34" charset="0"/>
+                      </a:endParaRPr>
+                    </a:p>
+                  </a:txBody>
+                  <a:tcPr marL="6350" marR="6350" marT="6350" marB="0" anchor="b"/>
+                </a:tc>
+                <a:extLst>
+                  <a:ext uri="{0D108BD9-81ED-4DB2-BD59-A6C34878D82A}">
+                    <a16:rowId xmlns:a16="http://schemas.microsoft.com/office/drawing/2014/main" val="3817753141"/>
+                  </a:ext>
+                </a:extLst>
+              </a:tr>
+              <a:tr h="431734">
+                <a:tc>
+                  <a:txBody>
+                    <a:bodyPr/>
+                    <a:lstStyle/>
+                    <a:p>
+                      <a:pPr algn="l" fontAlgn="b">
+                        <a:buNone/>
+                      </a:pPr>
+                      <a:r>
+                        <a:rPr lang="en-US" sz="2000" u="none" strike="noStrike" dirty="0">
+                          <a:effectLst/>
+                        </a:rPr>
+                        <a:t>Temperature</a:t>
+                      </a:r>
+                      <a:endParaRPr lang="en-US" sz="2000" b="0" i="0" u="none" strike="noStrike" dirty="0">
+                        <a:solidFill>
+                          <a:srgbClr val="000000"/>
+                        </a:solidFill>
+                        <a:effectLst/>
+                        <a:latin typeface="Calibri" panose="020F0502020204030204" pitchFamily="34" charset="0"/>
+                      </a:endParaRPr>
+                    </a:p>
+                  </a:txBody>
+                  <a:tcPr marL="6350" marR="6350" marT="6350" marB="0" anchor="b">
+                    <a:solidFill>
+                      <a:schemeClr val="bg1"/>
+                    </a:solidFill>
+                  </a:tcPr>
+                </a:tc>
+                <a:tc>
+                  <a:txBody>
+                    <a:bodyPr/>
+                    <a:lstStyle/>
+                    <a:p>
+                      <a:pPr algn="l" fontAlgn="b">
+                        <a:buNone/>
+                      </a:pPr>
+                      <a:r>
+                        <a:rPr lang="en-US" sz="2000" u="none" strike="noStrike" dirty="0">
+                          <a:effectLst/>
+                        </a:rPr>
+                        <a:t>Drought Code (DC)</a:t>
+                      </a:r>
+                      <a:endParaRPr lang="en-US" sz="2000" b="0" i="0" u="none" strike="noStrike" dirty="0">
+                        <a:solidFill>
+                          <a:srgbClr val="000000"/>
+                        </a:solidFill>
+                        <a:effectLst/>
+                        <a:latin typeface="Calibri" panose="020F0502020204030204" pitchFamily="34" charset="0"/>
+                      </a:endParaRPr>
+                    </a:p>
+                  </a:txBody>
+                  <a:tcPr marL="6350" marR="6350" marT="6350" marB="0" anchor="b">
+                    <a:solidFill>
+                      <a:schemeClr val="bg1"/>
+                    </a:solidFill>
+                  </a:tcPr>
+                </a:tc>
+                <a:extLst>
+                  <a:ext uri="{0D108BD9-81ED-4DB2-BD59-A6C34878D82A}">
+                    <a16:rowId xmlns:a16="http://schemas.microsoft.com/office/drawing/2014/main" val="2683222788"/>
+                  </a:ext>
+                </a:extLst>
+              </a:tr>
+              <a:tr h="431734">
+                <a:tc>
+                  <a:txBody>
+                    <a:bodyPr/>
+                    <a:lstStyle/>
+                    <a:p>
+                      <a:pPr algn="l" fontAlgn="b">
+                        <a:buNone/>
+                      </a:pPr>
+                      <a:r>
+                        <a:rPr lang="en-US" sz="2000" u="none" strike="noStrike">
+                          <a:effectLst/>
+                        </a:rPr>
+                        <a:t>RH (Relative Humidity)</a:t>
+                      </a:r>
+                      <a:endParaRPr lang="en-US" sz="2000" b="0" i="0" u="none" strike="noStrike">
+                        <a:solidFill>
+                          <a:srgbClr val="000000"/>
+                        </a:solidFill>
+                        <a:effectLst/>
+                        <a:latin typeface="Calibri" panose="020F0502020204030204" pitchFamily="34" charset="0"/>
+                      </a:endParaRPr>
+                    </a:p>
+                  </a:txBody>
+                  <a:tcPr marL="6350" marR="6350" marT="6350" marB="0" anchor="b"/>
+                </a:tc>
+                <a:tc>
+                  <a:txBody>
+                    <a:bodyPr/>
+                    <a:lstStyle/>
+                    <a:p>
+                      <a:pPr algn="l" fontAlgn="b">
+                        <a:buNone/>
+                      </a:pPr>
+                      <a:r>
+                        <a:rPr lang="en-US" sz="2000" u="none" strike="noStrike" dirty="0">
+                          <a:effectLst/>
+                        </a:rPr>
+                        <a:t>Initial Spread Index (ISI)</a:t>
+                      </a:r>
+                      <a:endParaRPr lang="en-US" sz="2000" b="0" i="0" u="none" strike="noStrike" dirty="0">
+                        <a:solidFill>
+                          <a:srgbClr val="000000"/>
+                        </a:solidFill>
+                        <a:effectLst/>
+                        <a:latin typeface="Calibri" panose="020F0502020204030204" pitchFamily="34" charset="0"/>
+                      </a:endParaRPr>
+                    </a:p>
+                  </a:txBody>
+                  <a:tcPr marL="6350" marR="6350" marT="6350" marB="0" anchor="b"/>
+                </a:tc>
+                <a:extLst>
+                  <a:ext uri="{0D108BD9-81ED-4DB2-BD59-A6C34878D82A}">
+                    <a16:rowId xmlns:a16="http://schemas.microsoft.com/office/drawing/2014/main" val="3184126084"/>
+                  </a:ext>
+                </a:extLst>
+              </a:tr>
+              <a:tr h="431734">
+                <a:tc>
+                  <a:txBody>
+                    <a:bodyPr/>
+                    <a:lstStyle/>
+                    <a:p>
+                      <a:pPr algn="l" fontAlgn="b">
+                        <a:buNone/>
+                      </a:pPr>
+                      <a:r>
+                        <a:rPr lang="en-US" sz="2000" u="none" strike="noStrike" dirty="0" err="1">
+                          <a:effectLst/>
+                          <a:latin typeface="Garamond" panose="02020404030301010803" pitchFamily="18" charset="0"/>
+                        </a:rPr>
+                        <a:t>Ws</a:t>
+                      </a:r>
+                      <a:r>
+                        <a:rPr lang="en-US" sz="2000" u="none" strike="noStrike" dirty="0">
+                          <a:effectLst/>
+                          <a:latin typeface="Garamond" panose="02020404030301010803" pitchFamily="18" charset="0"/>
+                        </a:rPr>
+                        <a:t> (Wind Speed)</a:t>
+                      </a:r>
+                      <a:endParaRPr lang="en-US" sz="2000" b="0" i="0" u="none" strike="noStrike" dirty="0">
+                        <a:solidFill>
+                          <a:srgbClr val="000000"/>
+                        </a:solidFill>
+                        <a:effectLst/>
+                        <a:latin typeface="Garamond" panose="02020404030301010803" pitchFamily="18" charset="0"/>
+                      </a:endParaRPr>
+                    </a:p>
+                  </a:txBody>
+                  <a:tcPr marL="6350" marR="6350" marT="6350" marB="0" anchor="b">
+                    <a:solidFill>
+                      <a:schemeClr val="bg1"/>
+                    </a:solidFill>
+                  </a:tcPr>
+                </a:tc>
+                <a:tc>
+                  <a:txBody>
+                    <a:bodyPr/>
+                    <a:lstStyle/>
+                    <a:p>
+                      <a:pPr algn="l" fontAlgn="b">
+                        <a:buNone/>
+                      </a:pPr>
+                      <a:r>
+                        <a:rPr lang="en-US" sz="2000" b="0" i="0" u="none" strike="noStrike" dirty="0">
+                          <a:solidFill>
+                            <a:srgbClr val="000000"/>
+                          </a:solidFill>
+                          <a:effectLst/>
+                          <a:latin typeface="Garamond" panose="02020404030301010803" pitchFamily="18" charset="0"/>
+                        </a:rPr>
+                        <a:t>Rain</a:t>
+                      </a:r>
+                    </a:p>
+                  </a:txBody>
+                  <a:tcPr marL="6350" marR="6350" marT="6350" marB="0" anchor="b">
+                    <a:solidFill>
+                      <a:schemeClr val="bg1"/>
+                    </a:solidFill>
+                  </a:tcPr>
+                </a:tc>
+                <a:extLst>
+                  <a:ext uri="{0D108BD9-81ED-4DB2-BD59-A6C34878D82A}">
+                    <a16:rowId xmlns:a16="http://schemas.microsoft.com/office/drawing/2014/main" val="120684806"/>
+                  </a:ext>
+                </a:extLst>
+              </a:tr>
+            </a:tbl>
+          </a:graphicData>
+        </a:graphic>
+      </p:graphicFrame>
     </p:spTree>
     <p:extLst>
       <p:ext uri="{BB962C8B-B14F-4D97-AF65-F5344CB8AC3E}">
@@ -22253,7 +22581,7 @@
               <a:rPr lang="en-US" dirty="0">
                 <a:latin typeface="Garamond" panose="02020404030301010803" pitchFamily="18" charset="0"/>
               </a:rPr>
-              <a:t> : 0</a:t>
+              <a:t>: 0</a:t>
             </a:r>
           </a:p>
           <a:p>
@@ -22394,7 +22722,7 @@
           <a:p>
             <a:pPr algn="ctr"/>
             <a:r>
-              <a:rPr lang="en-US" sz="1800" b="1" kern="100" dirty="0">
+              <a:rPr lang="en-US" sz="3200" b="1" kern="100" dirty="0">
                 <a:effectLst/>
                 <a:latin typeface="Garamond" panose="02020404030301010803" pitchFamily="18" charset="0"/>
                 <a:ea typeface="Calibri" panose="020F0502020204030204" pitchFamily="34" charset="0"/>
@@ -22406,19 +22734,7 @@
           <a:p>
             <a:pPr algn="ctr"/>
             <a:r>
-              <a:rPr lang="en-US" sz="1800" b="1" kern="100" dirty="0">
-                <a:effectLst/>
-                <a:latin typeface="Garamond" panose="02020404030301010803" pitchFamily="18" charset="0"/>
-                <a:ea typeface="Calibri" panose="020F0502020204030204" pitchFamily="34" charset="0"/>
-                <a:cs typeface="Times New Roman" panose="02020603050405020304" pitchFamily="18" charset="0"/>
-              </a:rPr>
-              <a:t>Linear Regression</a:t>
-            </a:r>
-          </a:p>
-          <a:p>
-            <a:pPr algn="ctr"/>
-            <a:r>
-              <a:rPr lang="en-US" sz="1800" b="1" kern="100" dirty="0">
+              <a:rPr lang="en-US" sz="3200" b="1" kern="100" dirty="0">
                 <a:effectLst/>
                 <a:latin typeface="Garamond" panose="02020404030301010803" pitchFamily="18" charset="0"/>
                 <a:ea typeface="Calibri" panose="020F0502020204030204" pitchFamily="34" charset="0"/>
@@ -22426,6 +22742,23 @@
               </a:rPr>
               <a:t>Decision Tree regression</a:t>
             </a:r>
+          </a:p>
+          <a:p>
+            <a:pPr algn="ctr"/>
+            <a:r>
+              <a:rPr lang="en-US" sz="3200" b="1" kern="100" dirty="0">
+                <a:latin typeface="Garamond" panose="02020404030301010803" pitchFamily="18" charset="0"/>
+                <a:ea typeface="Calibri" panose="020F0502020204030204" pitchFamily="34" charset="0"/>
+                <a:cs typeface="Times New Roman" panose="02020603050405020304" pitchFamily="18" charset="0"/>
+              </a:rPr>
+              <a:t>Random Forest Regression</a:t>
+            </a:r>
+            <a:endParaRPr lang="en-US" sz="3200" b="1" kern="100" dirty="0">
+              <a:effectLst/>
+              <a:latin typeface="Garamond" panose="02020404030301010803" pitchFamily="18" charset="0"/>
+              <a:ea typeface="Calibri" panose="020F0502020204030204" pitchFamily="34" charset="0"/>
+              <a:cs typeface="Times New Roman" panose="02020603050405020304" pitchFamily="18" charset="0"/>
+            </a:endParaRPr>
           </a:p>
           <a:p>
             <a:endParaRPr lang="en-US" dirty="0">
@@ -22507,44 +22840,6 @@
           </a:p>
         </p:txBody>
       </p:sp>
-      <p:pic>
-        <p:nvPicPr>
-          <p:cNvPr id="7" name="Content Placeholder 6">
-            <a:extLst>
-              <a:ext uri="{FF2B5EF4-FFF2-40B4-BE49-F238E27FC236}">
-                <a16:creationId xmlns:a16="http://schemas.microsoft.com/office/drawing/2014/main" id="{A3B21C1D-82DA-7085-21E3-A22657049F71}"/>
-              </a:ext>
-            </a:extLst>
-          </p:cNvPr>
-          <p:cNvPicPr>
-            <a:picLocks noGrp="1" noChangeAspect="1"/>
-          </p:cNvPicPr>
-          <p:nvPr>
-            <p:ph sz="quarter" idx="13"/>
-          </p:nvPr>
-        </p:nvPicPr>
-        <p:blipFill>
-          <a:blip r:embed="rId2">
-            <a:extLst>
-              <a:ext uri="{28A0092B-C50C-407E-A947-70E740481C1C}">
-                <a14:useLocalDpi xmlns:a14="http://schemas.microsoft.com/office/drawing/2010/main" val="0"/>
-              </a:ext>
-            </a:extLst>
-          </a:blip>
-          <a:stretch>
-            <a:fillRect/>
-          </a:stretch>
-        </p:blipFill>
-        <p:spPr>
-          <a:xfrm>
-            <a:off x="5651976" y="2173586"/>
-            <a:ext cx="6199187" cy="4227213"/>
-          </a:xfrm>
-          <a:prstGeom prst="rect">
-            <a:avLst/>
-          </a:prstGeom>
-        </p:spPr>
-      </p:pic>
       <p:sp>
         <p:nvSpPr>
           <p:cNvPr id="5" name="Text Placeholder 4">
@@ -22569,11 +22864,11 @@
         </p:spPr>
         <p:txBody>
           <a:bodyPr>
-            <a:normAutofit lnSpcReduction="10000"/>
+            <a:normAutofit/>
           </a:bodyPr>
           <a:lstStyle/>
           <a:p>
-            <a:pPr marL="0" marR="0" algn="just">
+            <a:pPr algn="just">
               <a:lnSpc>
                 <a:spcPct val="107000"/>
               </a:lnSpc>
@@ -22585,24 +22880,14 @@
               </a:spcAft>
             </a:pPr>
             <a:r>
-              <a:rPr lang="en-US" sz="2000" b="1" kern="100" dirty="0">
-                <a:effectLst/>
+              <a:rPr lang="en-US" sz="1800" b="1" kern="100" dirty="0">
                 <a:latin typeface="Garamond" panose="02020404030301010803" pitchFamily="18" charset="0"/>
                 <a:ea typeface="Calibri" panose="020F0502020204030204" pitchFamily="34" charset="0"/>
                 <a:cs typeface="Times New Roman" panose="02020603050405020304" pitchFamily="18" charset="0"/>
               </a:rPr>
-              <a:t>PERFORMANCE METRICS</a:t>
+              <a:t>Performance metrics result</a:t>
             </a:r>
-            <a:r>
-              <a:rPr lang="en-US" sz="2000" b="1" kern="100" dirty="0">
-                <a:latin typeface="Garamond" panose="02020404030301010803" pitchFamily="18" charset="0"/>
-                <a:ea typeface="Calibri" panose="020F0502020204030204" pitchFamily="34" charset="0"/>
-                <a:cs typeface="Times New Roman" panose="02020603050405020304" pitchFamily="18" charset="0"/>
-              </a:rPr>
-              <a:t> RESULTS</a:t>
-            </a:r>
-            <a:endParaRPr lang="en-US" sz="2000" b="1" kern="100" dirty="0">
-              <a:effectLst/>
+            <a:endParaRPr lang="en-US" sz="1800" kern="100" dirty="0">
               <a:latin typeface="Garamond" panose="02020404030301010803" pitchFamily="18" charset="0"/>
               <a:ea typeface="Calibri" panose="020F0502020204030204" pitchFamily="34" charset="0"/>
               <a:cs typeface="Times New Roman" panose="02020603050405020304" pitchFamily="18" charset="0"/>
@@ -22628,21 +22913,19 @@
             </a:pPr>
             <a:r>
               <a:rPr lang="en-US" sz="1800" b="1" kern="100" dirty="0">
-                <a:effectLst/>
                 <a:latin typeface="Garamond" panose="02020404030301010803" pitchFamily="18" charset="0"/>
                 <a:ea typeface="Calibri" panose="020F0502020204030204" pitchFamily="34" charset="0"/>
                 <a:cs typeface="Times New Roman" panose="02020603050405020304" pitchFamily="18" charset="0"/>
               </a:rPr>
-              <a:t>Accuracy:</a:t>
+              <a:t>Accuracy: </a:t>
             </a:r>
             <a:r>
               <a:rPr lang="en-US" sz="1800" kern="100" dirty="0">
-                <a:effectLst/>
                 <a:latin typeface="Garamond" panose="02020404030301010803" pitchFamily="18" charset="0"/>
                 <a:ea typeface="Calibri" panose="020F0502020204030204" pitchFamily="34" charset="0"/>
                 <a:cs typeface="Times New Roman" panose="02020603050405020304" pitchFamily="18" charset="0"/>
               </a:rPr>
-              <a:t> 0.535 (53.5% of predictions are correct)</a:t>
+              <a:t>65.8%</a:t>
             </a:r>
           </a:p>
           <a:p>
@@ -22665,7 +22948,6 @@
             </a:pPr>
             <a:r>
               <a:rPr lang="en-US" sz="1800" b="1" kern="100" dirty="0">
-                <a:effectLst/>
                 <a:latin typeface="Garamond" panose="02020404030301010803" pitchFamily="18" charset="0"/>
                 <a:ea typeface="Calibri" panose="020F0502020204030204" pitchFamily="34" charset="0"/>
                 <a:cs typeface="Times New Roman" panose="02020603050405020304" pitchFamily="18" charset="0"/>
@@ -22674,12 +22956,11 @@
             </a:r>
             <a:r>
               <a:rPr lang="en-US" sz="1800" kern="100" dirty="0">
-                <a:effectLst/>
                 <a:latin typeface="Garamond" panose="02020404030301010803" pitchFamily="18" charset="0"/>
                 <a:ea typeface="Calibri" panose="020F0502020204030204" pitchFamily="34" charset="0"/>
                 <a:cs typeface="Times New Roman" panose="02020603050405020304" pitchFamily="18" charset="0"/>
               </a:rPr>
-              <a:t> 0.373 (37.3% of actual fires are correctly identified)</a:t>
+              <a:t> 82.6%</a:t>
             </a:r>
           </a:p>
           <a:p>
@@ -22702,7 +22983,6 @@
             </a:pPr>
             <a:r>
               <a:rPr lang="en-US" sz="1800" b="1" kern="100" dirty="0">
-                <a:effectLst/>
                 <a:latin typeface="Garamond" panose="02020404030301010803" pitchFamily="18" charset="0"/>
                 <a:ea typeface="Calibri" panose="020F0502020204030204" pitchFamily="34" charset="0"/>
                 <a:cs typeface="Times New Roman" panose="02020603050405020304" pitchFamily="18" charset="0"/>
@@ -22711,12 +22991,11 @@
             </a:r>
             <a:r>
               <a:rPr lang="en-US" sz="1800" kern="100" dirty="0">
-                <a:effectLst/>
                 <a:latin typeface="Garamond" panose="02020404030301010803" pitchFamily="18" charset="0"/>
                 <a:ea typeface="Calibri" panose="020F0502020204030204" pitchFamily="34" charset="0"/>
                 <a:cs typeface="Times New Roman" panose="02020603050405020304" pitchFamily="18" charset="0"/>
               </a:rPr>
-              <a:t> 0.662 (66.2% of non-fire days are correctly identified)</a:t>
+              <a:t> 44.1%</a:t>
             </a:r>
           </a:p>
           <a:p>
@@ -22739,21 +23018,19 @@
             </a:pPr>
             <a:r>
               <a:rPr lang="en-US" sz="1800" b="1" kern="100" dirty="0">
-                <a:effectLst/>
                 <a:latin typeface="Garamond" panose="02020404030301010803" pitchFamily="18" charset="0"/>
                 <a:ea typeface="Calibri" panose="020F0502020204030204" pitchFamily="34" charset="0"/>
                 <a:cs typeface="Times New Roman" panose="02020603050405020304" pitchFamily="18" charset="0"/>
               </a:rPr>
-              <a:t>ROC AUC:</a:t>
+              <a:t>ROC AUC: </a:t>
             </a:r>
             <a:r>
               <a:rPr lang="en-US" sz="1800" kern="100" dirty="0">
-                <a:effectLst/>
                 <a:latin typeface="Garamond" panose="02020404030301010803" pitchFamily="18" charset="0"/>
                 <a:ea typeface="Calibri" panose="020F0502020204030204" pitchFamily="34" charset="0"/>
                 <a:cs typeface="Times New Roman" panose="02020603050405020304" pitchFamily="18" charset="0"/>
               </a:rPr>
-              <a:t> 0.552 (The model has limited ability to distinguish between fire and no fire events)</a:t>
+              <a:t>0.696</a:t>
             </a:r>
           </a:p>
           <a:p>
@@ -22779,7 +23056,7 @@
           <p:nvPr>
             <p:extLst>
               <p:ext uri="{D42A27DB-BD31-4B8C-83A1-F6EECF244321}">
-                <p14:modId xmlns:p14="http://schemas.microsoft.com/office/powerpoint/2010/main" val="3746621427"/>
+                <p14:modId xmlns:p14="http://schemas.microsoft.com/office/powerpoint/2010/main" val="600674811"/>
               </p:ext>
             </p:extLst>
           </p:nvPr>
@@ -22824,7 +23101,7 @@
                     <a:lstStyle/>
                     <a:p>
                       <a:r>
-                        <a:rPr lang="en-US" sz="2800" dirty="0">
+                        <a:rPr lang="en-US" sz="2400" dirty="0">
                           <a:latin typeface="Garamond" panose="02020404030301010803" pitchFamily="18" charset="0"/>
                         </a:rPr>
                         <a:t>Conf. Matrix</a:t>
@@ -22839,7 +23116,7 @@
                     <a:lstStyle/>
                     <a:p>
                       <a:r>
-                        <a:rPr lang="en-US" sz="2800" dirty="0">
+                        <a:rPr lang="en-US" sz="2400" dirty="0">
                           <a:latin typeface="Garamond" panose="02020404030301010803" pitchFamily="18" charset="0"/>
                         </a:rPr>
                         <a:t>POSITIVE</a:t>
@@ -22854,7 +23131,7 @@
                     <a:lstStyle/>
                     <a:p>
                       <a:r>
-                        <a:rPr lang="en-US" sz="2800" dirty="0">
+                        <a:rPr lang="en-US" sz="2400" dirty="0">
                           <a:latin typeface="Garamond" panose="02020404030301010803" pitchFamily="18" charset="0"/>
                         </a:rPr>
                         <a:t>NEGATIVE</a:t>
@@ -22876,7 +23153,7 @@
                     <a:lstStyle/>
                     <a:p>
                       <a:r>
-                        <a:rPr lang="en-US" sz="2800" dirty="0">
+                        <a:rPr lang="en-US" sz="2400" dirty="0">
                           <a:latin typeface="Garamond" panose="02020404030301010803" pitchFamily="18" charset="0"/>
                         </a:rPr>
                         <a:t>POSITIVE</a:t>
@@ -22891,10 +23168,10 @@
                     <a:lstStyle/>
                     <a:p>
                       <a:r>
-                        <a:rPr lang="en-US" sz="2800" dirty="0">
+                        <a:rPr lang="en-US" sz="2400" dirty="0">
                           <a:latin typeface="Garamond" panose="02020404030301010803" pitchFamily="18" charset="0"/>
                         </a:rPr>
-                        <a:t>137</a:t>
+                        <a:t>71</a:t>
                       </a:r>
                     </a:p>
                   </a:txBody>
@@ -22906,10 +23183,10 @@
                     <a:lstStyle/>
                     <a:p>
                       <a:r>
-                        <a:rPr lang="en-US" sz="2800" dirty="0">
+                        <a:rPr lang="en-US" sz="2400" dirty="0">
                           <a:latin typeface="Garamond" panose="02020404030301010803" pitchFamily="18" charset="0"/>
                         </a:rPr>
-                        <a:t>70</a:t>
+                        <a:t>36</a:t>
                       </a:r>
                     </a:p>
                   </a:txBody>
@@ -22928,7 +23205,7 @@
                     <a:lstStyle/>
                     <a:p>
                       <a:r>
-                        <a:rPr lang="en-US" sz="2800" dirty="0">
+                        <a:rPr lang="en-US" sz="2400" dirty="0">
                           <a:latin typeface="Garamond" panose="02020404030301010803" pitchFamily="18" charset="0"/>
                         </a:rPr>
                         <a:t>NEGATIVE</a:t>
@@ -22943,10 +23220,10 @@
                     <a:lstStyle/>
                     <a:p>
                       <a:r>
-                        <a:rPr lang="en-US" sz="2800" dirty="0">
+                        <a:rPr lang="en-US" sz="2400" dirty="0">
                           <a:latin typeface="Garamond" panose="02020404030301010803" pitchFamily="18" charset="0"/>
                         </a:rPr>
-                        <a:t>101</a:t>
+                        <a:t>90</a:t>
                       </a:r>
                     </a:p>
                   </a:txBody>
@@ -22958,10 +23235,10 @@
                     <a:lstStyle/>
                     <a:p>
                       <a:r>
-                        <a:rPr lang="en-US" sz="2800" dirty="0">
+                        <a:rPr lang="en-US" sz="2400" dirty="0">
                           <a:latin typeface="Garamond" panose="02020404030301010803" pitchFamily="18" charset="0"/>
                         </a:rPr>
-                        <a:t>60</a:t>
+                        <a:t>171</a:t>
                       </a:r>
                     </a:p>
                   </a:txBody>
@@ -22991,8 +23268,8 @@
         </p:nvSpPr>
         <p:spPr>
           <a:xfrm>
-            <a:off x="127625" y="4993264"/>
-            <a:ext cx="5334000" cy="1268489"/>
+            <a:off x="127625" y="4177450"/>
+            <a:ext cx="4981270" cy="1477328"/>
           </a:xfrm>
           <a:prstGeom prst="rect">
             <a:avLst/>
@@ -23002,6 +23279,169 @@
         <p:txBody>
           <a:bodyPr wrap="square">
             <a:spAutoFit/>
+          </a:bodyPr>
+          <a:lstStyle/>
+          <a:p>
+            <a:pPr algn="ctr" latinLnBrk="1"/>
+            <a:r>
+              <a:rPr lang="en-US" b="1" dirty="0">
+                <a:latin typeface="Garamond" panose="02020404030301010803" pitchFamily="18" charset="0"/>
+              </a:rPr>
+              <a:t>OUTPUT:</a:t>
+            </a:r>
+          </a:p>
+          <a:p>
+            <a:pPr algn="just" latinLnBrk="1"/>
+            <a:r>
+              <a:rPr lang="en-US" dirty="0">
+                <a:latin typeface="Garamond" panose="02020404030301010803" pitchFamily="18" charset="0"/>
+              </a:rPr>
+              <a:t>The logistic regression model correctly predicts 66% of all cases. It catches 83% of actual fires but generates 90 false alarms. Best for overall accuracy when false alarms are acceptable.</a:t>
+            </a:r>
+          </a:p>
+        </p:txBody>
+      </p:sp>
+      <p:pic>
+        <p:nvPicPr>
+          <p:cNvPr id="9" name="Picture 8">
+            <a:extLst>
+              <a:ext uri="{FF2B5EF4-FFF2-40B4-BE49-F238E27FC236}">
+                <a16:creationId xmlns:a16="http://schemas.microsoft.com/office/drawing/2014/main" id="{17CBB5D8-A7C9-7535-5BFE-5E18CA5A038E}"/>
+              </a:ext>
+            </a:extLst>
+          </p:cNvPr>
+          <p:cNvPicPr>
+            <a:picLocks noChangeAspect="1"/>
+          </p:cNvPicPr>
+          <p:nvPr/>
+        </p:nvPicPr>
+        <p:blipFill>
+          <a:blip r:embed="rId2">
+            <a:extLst>
+              <a:ext uri="{28A0092B-C50C-407E-A947-70E740481C1C}">
+                <a14:useLocalDpi xmlns:a14="http://schemas.microsoft.com/office/drawing/2010/main" val="0"/>
+              </a:ext>
+            </a:extLst>
+          </a:blip>
+          <a:stretch>
+            <a:fillRect/>
+          </a:stretch>
+        </p:blipFill>
+        <p:spPr>
+          <a:xfrm>
+            <a:off x="6214109" y="2173587"/>
+            <a:ext cx="5074921" cy="4560263"/>
+          </a:xfrm>
+          <a:prstGeom prst="rect">
+            <a:avLst/>
+          </a:prstGeom>
+        </p:spPr>
+      </p:pic>
+    </p:spTree>
+    <p:extLst>
+      <p:ext uri="{BB962C8B-B14F-4D97-AF65-F5344CB8AC3E}">
+        <p14:creationId xmlns:p14="http://schemas.microsoft.com/office/powerpoint/2010/main" val="2431895255"/>
+      </p:ext>
+    </p:extLst>
+  </p:cSld>
+  <p:clrMapOvr>
+    <a:masterClrMapping/>
+  </p:clrMapOvr>
+</p:sld>
+</file>
+
+<file path=ppt/slides/slide6.xml><?xml version="1.0" encoding="utf-8"?>
+<p:sld xmlns:a="http://schemas.openxmlformats.org/drawingml/2006/main" xmlns:r="http://schemas.openxmlformats.org/officeDocument/2006/relationships" xmlns:p="http://schemas.openxmlformats.org/presentationml/2006/main">
+  <p:cSld>
+    <p:spTree>
+      <p:nvGrpSpPr>
+        <p:cNvPr id="1" name=""/>
+        <p:cNvGrpSpPr/>
+        <p:nvPr/>
+      </p:nvGrpSpPr>
+      <p:grpSpPr>
+        <a:xfrm>
+          <a:off x="0" y="0"/>
+          <a:ext cx="0" cy="0"/>
+          <a:chOff x="0" y="0"/>
+          <a:chExt cx="0" cy="0"/>
+        </a:xfrm>
+      </p:grpSpPr>
+      <p:sp>
+        <p:nvSpPr>
+          <p:cNvPr id="2" name="Title 1">
+            <a:extLst>
+              <a:ext uri="{FF2B5EF4-FFF2-40B4-BE49-F238E27FC236}">
+                <a16:creationId xmlns:a16="http://schemas.microsoft.com/office/drawing/2014/main" id="{FD571192-1759-0360-10E9-454E61B49FBD}"/>
+              </a:ext>
+            </a:extLst>
+          </p:cNvPr>
+          <p:cNvSpPr>
+            <a:spLocks noGrp="1"/>
+          </p:cNvSpPr>
+          <p:nvPr>
+            <p:ph type="title"/>
+          </p:nvPr>
+        </p:nvSpPr>
+        <p:spPr>
+          <a:xfrm>
+            <a:off x="745995" y="1326093"/>
+            <a:ext cx="3935688" cy="1121538"/>
+          </a:xfrm>
+        </p:spPr>
+        <p:txBody>
+          <a:bodyPr>
+            <a:normAutofit fontScale="90000"/>
+          </a:bodyPr>
+          <a:lstStyle/>
+          <a:p>
+            <a:r>
+              <a:rPr lang="en-US" b="1" dirty="0">
+                <a:latin typeface="Garamond" panose="02020404030301010803" pitchFamily="18" charset="0"/>
+              </a:rPr>
+              <a:t>Decision tree regression</a:t>
+            </a:r>
+            <a:br>
+              <a:rPr lang="en-US" dirty="0">
+                <a:latin typeface="Garamond" panose="02020404030301010803" pitchFamily="18" charset="0"/>
+              </a:rPr>
+            </a:br>
+            <a:br>
+              <a:rPr lang="en-US" dirty="0">
+                <a:latin typeface="Garamond" panose="02020404030301010803" pitchFamily="18" charset="0"/>
+              </a:rPr>
+            </a:br>
+            <a:endParaRPr lang="en-US" dirty="0">
+              <a:latin typeface="Garamond" panose="02020404030301010803" pitchFamily="18" charset="0"/>
+            </a:endParaRPr>
+          </a:p>
+        </p:txBody>
+      </p:sp>
+      <p:sp>
+        <p:nvSpPr>
+          <p:cNvPr id="4" name="Text Placeholder 3">
+            <a:extLst>
+              <a:ext uri="{FF2B5EF4-FFF2-40B4-BE49-F238E27FC236}">
+                <a16:creationId xmlns:a16="http://schemas.microsoft.com/office/drawing/2014/main" id="{522E5C78-4CBC-3C1F-AD75-A719E7032835}"/>
+              </a:ext>
+            </a:extLst>
+          </p:cNvPr>
+          <p:cNvSpPr>
+            <a:spLocks noGrp="1"/>
+          </p:cNvSpPr>
+          <p:nvPr>
+            <p:ph type="body" sz="half" idx="2"/>
+          </p:nvPr>
+        </p:nvSpPr>
+        <p:spPr>
+          <a:xfrm>
+            <a:off x="253998" y="1699261"/>
+            <a:ext cx="4595463" cy="2971800"/>
+          </a:xfrm>
+        </p:spPr>
+        <p:txBody>
+          <a:bodyPr>
+            <a:normAutofit/>
           </a:bodyPr>
           <a:lstStyle/>
           <a:p>
@@ -23017,14 +23457,490 @@
               </a:spcAft>
             </a:pPr>
             <a:r>
+              <a:rPr lang="en-US" sz="1800" b="1" kern="100" dirty="0">
+                <a:effectLst/>
+                <a:latin typeface="Garamond" panose="02020404030301010803" pitchFamily="18" charset="0"/>
+                <a:ea typeface="Calibri" panose="020F0502020204030204" pitchFamily="34" charset="0"/>
+                <a:cs typeface="Times New Roman" panose="02020603050405020304" pitchFamily="18" charset="0"/>
+              </a:rPr>
+              <a:t>Performance metrics</a:t>
+            </a:r>
+            <a:r>
+              <a:rPr lang="en-US" sz="1800" b="1" kern="100" dirty="0">
+                <a:latin typeface="Garamond" panose="02020404030301010803" pitchFamily="18" charset="0"/>
+                <a:ea typeface="Calibri" panose="020F0502020204030204" pitchFamily="34" charset="0"/>
+                <a:cs typeface="Times New Roman" panose="02020603050405020304" pitchFamily="18" charset="0"/>
+              </a:rPr>
+              <a:t> result</a:t>
+            </a:r>
+            <a:endParaRPr lang="en-US" sz="1800" kern="100" dirty="0">
+              <a:effectLst/>
+              <a:latin typeface="Garamond" panose="02020404030301010803" pitchFamily="18" charset="0"/>
+              <a:ea typeface="Calibri" panose="020F0502020204030204" pitchFamily="34" charset="0"/>
+              <a:cs typeface="Times New Roman" panose="02020603050405020304" pitchFamily="18" charset="0"/>
+            </a:endParaRPr>
+          </a:p>
+          <a:p>
+            <a:pPr marL="342900" marR="0" lvl="0" indent="-342900" algn="just">
+              <a:lnSpc>
+                <a:spcPct val="107000"/>
+              </a:lnSpc>
+              <a:spcBef>
+                <a:spcPts val="0"/>
+              </a:spcBef>
+              <a:spcAft>
+                <a:spcPts val="800"/>
+              </a:spcAft>
+              <a:buSzPts val="1000"/>
+              <a:buFont typeface="Symbol" panose="05050102010706020507" pitchFamily="18" charset="2"/>
+              <a:buChar char=""/>
+              <a:tabLst>
+                <a:tab pos="457200" algn="l"/>
+              </a:tabLst>
+            </a:pPr>
+            <a:r>
+              <a:rPr lang="en-US" sz="1800" b="1" kern="100" dirty="0">
+                <a:effectLst/>
+                <a:latin typeface="Garamond" panose="02020404030301010803" pitchFamily="18" charset="0"/>
+                <a:ea typeface="Calibri" panose="020F0502020204030204" pitchFamily="34" charset="0"/>
+                <a:cs typeface="Times New Roman" panose="02020603050405020304" pitchFamily="18" charset="0"/>
+              </a:rPr>
+              <a:t>Accuracy: </a:t>
+            </a:r>
+            <a:r>
               <a:rPr lang="en-US" sz="1800" kern="100" dirty="0">
                 <a:effectLst/>
                 <a:latin typeface="Garamond" panose="02020404030301010803" pitchFamily="18" charset="0"/>
                 <a:ea typeface="Calibri" panose="020F0502020204030204" pitchFamily="34" charset="0"/>
                 <a:cs typeface="Times New Roman" panose="02020603050405020304" pitchFamily="18" charset="0"/>
               </a:rPr>
-              <a:t>The logistic regression model performs slightly better than random guessing. It is more effective at correctly identifying non-fire events than fire events, which is reflected in the higher specificity compared to sensitivity.</a:t>
+              <a:t>63.9%</a:t>
             </a:r>
+            <a:endParaRPr lang="en-US" sz="1800" kern="100" dirty="0">
+              <a:latin typeface="Garamond" panose="02020404030301010803" pitchFamily="18" charset="0"/>
+              <a:ea typeface="Calibri" panose="020F0502020204030204" pitchFamily="34" charset="0"/>
+              <a:cs typeface="Times New Roman" panose="02020603050405020304" pitchFamily="18" charset="0"/>
+            </a:endParaRPr>
+          </a:p>
+          <a:p>
+            <a:pPr marL="342900" marR="0" lvl="0" indent="-342900" algn="just">
+              <a:lnSpc>
+                <a:spcPct val="107000"/>
+              </a:lnSpc>
+              <a:spcBef>
+                <a:spcPts val="0"/>
+              </a:spcBef>
+              <a:spcAft>
+                <a:spcPts val="800"/>
+              </a:spcAft>
+              <a:buSzPts val="1000"/>
+              <a:buFont typeface="Symbol" panose="05050102010706020507" pitchFamily="18" charset="2"/>
+              <a:buChar char=""/>
+              <a:tabLst>
+                <a:tab pos="457200" algn="l"/>
+              </a:tabLst>
+            </a:pPr>
+            <a:r>
+              <a:rPr lang="en-US" sz="1800" b="1" kern="100" dirty="0">
+                <a:effectLst/>
+                <a:latin typeface="Garamond" panose="02020404030301010803" pitchFamily="18" charset="0"/>
+                <a:ea typeface="Calibri" panose="020F0502020204030204" pitchFamily="34" charset="0"/>
+                <a:cs typeface="Times New Roman" panose="02020603050405020304" pitchFamily="18" charset="0"/>
+              </a:rPr>
+              <a:t>Sensitivity (Recall): </a:t>
+            </a:r>
+            <a:r>
+              <a:rPr lang="en-US" sz="1800" kern="100" dirty="0">
+                <a:effectLst/>
+                <a:latin typeface="Garamond" panose="02020404030301010803" pitchFamily="18" charset="0"/>
+                <a:ea typeface="Calibri" panose="020F0502020204030204" pitchFamily="34" charset="0"/>
+                <a:cs typeface="Times New Roman" panose="02020603050405020304" pitchFamily="18" charset="0"/>
+              </a:rPr>
+              <a:t>86.5% </a:t>
+            </a:r>
+          </a:p>
+          <a:p>
+            <a:pPr marL="342900" marR="0" lvl="0" indent="-342900" algn="just">
+              <a:lnSpc>
+                <a:spcPct val="107000"/>
+              </a:lnSpc>
+              <a:spcBef>
+                <a:spcPts val="0"/>
+              </a:spcBef>
+              <a:spcAft>
+                <a:spcPts val="800"/>
+              </a:spcAft>
+              <a:buSzPts val="1000"/>
+              <a:buFont typeface="Symbol" panose="05050102010706020507" pitchFamily="18" charset="2"/>
+              <a:buChar char=""/>
+              <a:tabLst>
+                <a:tab pos="457200" algn="l"/>
+              </a:tabLst>
+            </a:pPr>
+            <a:r>
+              <a:rPr lang="en-US" sz="1800" b="1" kern="100" dirty="0">
+                <a:effectLst/>
+                <a:latin typeface="Garamond" panose="02020404030301010803" pitchFamily="18" charset="0"/>
+                <a:ea typeface="Calibri" panose="020F0502020204030204" pitchFamily="34" charset="0"/>
+                <a:cs typeface="Times New Roman" panose="02020603050405020304" pitchFamily="18" charset="0"/>
+              </a:rPr>
+              <a:t>Specificity:</a:t>
+            </a:r>
+            <a:r>
+              <a:rPr lang="en-US" sz="1800" kern="100" dirty="0">
+                <a:effectLst/>
+                <a:latin typeface="Garamond" panose="02020404030301010803" pitchFamily="18" charset="0"/>
+                <a:ea typeface="Calibri" panose="020F0502020204030204" pitchFamily="34" charset="0"/>
+                <a:cs typeface="Times New Roman" panose="02020603050405020304" pitchFamily="18" charset="0"/>
+              </a:rPr>
+              <a:t> 34.8%</a:t>
+            </a:r>
+          </a:p>
+          <a:p>
+            <a:pPr marL="342900" marR="0" lvl="0" indent="-342900" algn="just">
+              <a:lnSpc>
+                <a:spcPct val="107000"/>
+              </a:lnSpc>
+              <a:spcBef>
+                <a:spcPts val="0"/>
+              </a:spcBef>
+              <a:spcAft>
+                <a:spcPts val="800"/>
+              </a:spcAft>
+              <a:buSzPts val="1000"/>
+              <a:buFont typeface="Symbol" panose="05050102010706020507" pitchFamily="18" charset="2"/>
+              <a:buChar char=""/>
+              <a:tabLst>
+                <a:tab pos="457200" algn="l"/>
+              </a:tabLst>
+            </a:pPr>
+            <a:r>
+              <a:rPr lang="en-US" sz="1800" b="1" kern="100" dirty="0">
+                <a:effectLst/>
+                <a:latin typeface="Garamond" panose="02020404030301010803" pitchFamily="18" charset="0"/>
+                <a:ea typeface="Calibri" panose="020F0502020204030204" pitchFamily="34" charset="0"/>
+                <a:cs typeface="Times New Roman" panose="02020603050405020304" pitchFamily="18" charset="0"/>
+              </a:rPr>
+              <a:t>ROC AUC: </a:t>
+            </a:r>
+            <a:r>
+              <a:rPr lang="en-US" sz="1800" kern="100" dirty="0">
+                <a:effectLst/>
+                <a:latin typeface="Garamond" panose="02020404030301010803" pitchFamily="18" charset="0"/>
+                <a:ea typeface="Calibri" panose="020F0502020204030204" pitchFamily="34" charset="0"/>
+                <a:cs typeface="Times New Roman" panose="02020603050405020304" pitchFamily="18" charset="0"/>
+              </a:rPr>
+              <a:t>0.701</a:t>
+            </a:r>
+          </a:p>
+          <a:p>
+            <a:pPr marL="342900" marR="0" lvl="0" indent="-342900" algn="just">
+              <a:lnSpc>
+                <a:spcPct val="107000"/>
+              </a:lnSpc>
+              <a:spcBef>
+                <a:spcPts val="0"/>
+              </a:spcBef>
+              <a:spcAft>
+                <a:spcPts val="800"/>
+              </a:spcAft>
+              <a:buSzPts val="1000"/>
+              <a:buFont typeface="Symbol" panose="05050102010706020507" pitchFamily="18" charset="2"/>
+              <a:buChar char=""/>
+              <a:tabLst>
+                <a:tab pos="457200" algn="l"/>
+              </a:tabLst>
+            </a:pPr>
+            <a:endParaRPr lang="en-US" dirty="0">
+              <a:latin typeface="Garamond" panose="02020404030301010803" pitchFamily="18" charset="0"/>
+            </a:endParaRPr>
+          </a:p>
+        </p:txBody>
+      </p:sp>
+      <p:graphicFrame>
+        <p:nvGraphicFramePr>
+          <p:cNvPr id="5" name="Table 4">
+            <a:extLst>
+              <a:ext uri="{FF2B5EF4-FFF2-40B4-BE49-F238E27FC236}">
+                <a16:creationId xmlns:a16="http://schemas.microsoft.com/office/drawing/2014/main" id="{C5583441-D335-B28D-37B1-0AA82B897492}"/>
+              </a:ext>
+            </a:extLst>
+          </p:cNvPr>
+          <p:cNvGraphicFramePr>
+            <a:graphicFrameLocks noGrp="1"/>
+          </p:cNvGraphicFramePr>
+          <p:nvPr>
+            <p:extLst>
+              <p:ext uri="{D42A27DB-BD31-4B8C-83A1-F6EECF244321}">
+                <p14:modId xmlns:p14="http://schemas.microsoft.com/office/powerpoint/2010/main" val="1164817211"/>
+              </p:ext>
+            </p:extLst>
+          </p:nvPr>
+        </p:nvGraphicFramePr>
+        <p:xfrm>
+          <a:off x="5341458" y="557532"/>
+          <a:ext cx="6366981" cy="1577340"/>
+        </p:xfrm>
+        <a:graphic>
+          <a:graphicData uri="http://schemas.openxmlformats.org/drawingml/2006/table">
+            <a:tbl>
+              <a:tblPr firstRow="1" bandRow="1">
+                <a:tableStyleId>{5C22544A-7EE6-4342-B048-85BDC9FD1C3A}</a:tableStyleId>
+              </a:tblPr>
+              <a:tblGrid>
+                <a:gridCol w="2122327">
+                  <a:extLst>
+                    <a:ext uri="{9D8B030D-6E8A-4147-A177-3AD203B41FA5}">
+                      <a16:colId xmlns:a16="http://schemas.microsoft.com/office/drawing/2014/main" val="3601434795"/>
+                    </a:ext>
+                  </a:extLst>
+                </a:gridCol>
+                <a:gridCol w="2122327">
+                  <a:extLst>
+                    <a:ext uri="{9D8B030D-6E8A-4147-A177-3AD203B41FA5}">
+                      <a16:colId xmlns:a16="http://schemas.microsoft.com/office/drawing/2014/main" val="2054355883"/>
+                    </a:ext>
+                  </a:extLst>
+                </a:gridCol>
+                <a:gridCol w="2122327">
+                  <a:extLst>
+                    <a:ext uri="{9D8B030D-6E8A-4147-A177-3AD203B41FA5}">
+                      <a16:colId xmlns:a16="http://schemas.microsoft.com/office/drawing/2014/main" val="2269804400"/>
+                    </a:ext>
+                  </a:extLst>
+                </a:gridCol>
+              </a:tblGrid>
+              <a:tr h="525780">
+                <a:tc>
+                  <a:txBody>
+                    <a:bodyPr/>
+                    <a:lstStyle/>
+                    <a:p>
+                      <a:r>
+                        <a:rPr lang="en-US" sz="2400" dirty="0">
+                          <a:latin typeface="Garamond" panose="02020404030301010803" pitchFamily="18" charset="0"/>
+                        </a:rPr>
+                        <a:t>Conf. Matrix</a:t>
+                      </a:r>
+                    </a:p>
+                  </a:txBody>
+                  <a:tcPr/>
+                </a:tc>
+                <a:tc>
+                  <a:txBody>
+                    <a:bodyPr/>
+                    <a:lstStyle/>
+                    <a:p>
+                      <a:r>
+                        <a:rPr lang="en-US" sz="2400" dirty="0">
+                          <a:latin typeface="Garamond" panose="02020404030301010803" pitchFamily="18" charset="0"/>
+                        </a:rPr>
+                        <a:t>POSITIVE</a:t>
+                      </a:r>
+                    </a:p>
+                  </a:txBody>
+                  <a:tcPr/>
+                </a:tc>
+                <a:tc>
+                  <a:txBody>
+                    <a:bodyPr/>
+                    <a:lstStyle/>
+                    <a:p>
+                      <a:r>
+                        <a:rPr lang="en-US" sz="2400" dirty="0">
+                          <a:latin typeface="Garamond" panose="02020404030301010803" pitchFamily="18" charset="0"/>
+                        </a:rPr>
+                        <a:t>NEGATIVE</a:t>
+                      </a:r>
+                    </a:p>
+                  </a:txBody>
+                  <a:tcPr/>
+                </a:tc>
+                <a:extLst>
+                  <a:ext uri="{0D108BD9-81ED-4DB2-BD59-A6C34878D82A}">
+                    <a16:rowId xmlns:a16="http://schemas.microsoft.com/office/drawing/2014/main" val="3091215264"/>
+                  </a:ext>
+                </a:extLst>
+              </a:tr>
+              <a:tr h="525780">
+                <a:tc>
+                  <a:txBody>
+                    <a:bodyPr/>
+                    <a:lstStyle/>
+                    <a:p>
+                      <a:r>
+                        <a:rPr lang="en-US" sz="2400" dirty="0">
+                          <a:latin typeface="Garamond" panose="02020404030301010803" pitchFamily="18" charset="0"/>
+                        </a:rPr>
+                        <a:t>POSITIVE</a:t>
+                      </a:r>
+                    </a:p>
+                  </a:txBody>
+                  <a:tcPr/>
+                </a:tc>
+                <a:tc>
+                  <a:txBody>
+                    <a:bodyPr/>
+                    <a:lstStyle/>
+                    <a:p>
+                      <a:r>
+                        <a:rPr lang="en-US" sz="2400" dirty="0">
+                          <a:latin typeface="Garamond" panose="02020404030301010803" pitchFamily="18" charset="0"/>
+                        </a:rPr>
+                        <a:t>56</a:t>
+                      </a:r>
+                    </a:p>
+                  </a:txBody>
+                  <a:tcPr/>
+                </a:tc>
+                <a:tc>
+                  <a:txBody>
+                    <a:bodyPr/>
+                    <a:lstStyle/>
+                    <a:p>
+                      <a:r>
+                        <a:rPr lang="en-US" sz="2400" dirty="0">
+                          <a:latin typeface="Garamond" panose="02020404030301010803" pitchFamily="18" charset="0"/>
+                        </a:rPr>
+                        <a:t>28</a:t>
+                      </a:r>
+                    </a:p>
+                  </a:txBody>
+                  <a:tcPr/>
+                </a:tc>
+                <a:extLst>
+                  <a:ext uri="{0D108BD9-81ED-4DB2-BD59-A6C34878D82A}">
+                    <a16:rowId xmlns:a16="http://schemas.microsoft.com/office/drawing/2014/main" val="4041805925"/>
+                  </a:ext>
+                </a:extLst>
+              </a:tr>
+              <a:tr h="525780">
+                <a:tc>
+                  <a:txBody>
+                    <a:bodyPr/>
+                    <a:lstStyle/>
+                    <a:p>
+                      <a:r>
+                        <a:rPr lang="en-US" sz="2400" dirty="0">
+                          <a:latin typeface="Garamond" panose="02020404030301010803" pitchFamily="18" charset="0"/>
+                        </a:rPr>
+                        <a:t>NEGATIVE</a:t>
+                      </a:r>
+                    </a:p>
+                  </a:txBody>
+                  <a:tcPr/>
+                </a:tc>
+                <a:tc>
+                  <a:txBody>
+                    <a:bodyPr/>
+                    <a:lstStyle/>
+                    <a:p>
+                      <a:r>
+                        <a:rPr lang="en-US" sz="2400" dirty="0">
+                          <a:latin typeface="Garamond" panose="02020404030301010803" pitchFamily="18" charset="0"/>
+                        </a:rPr>
+                        <a:t>105</a:t>
+                      </a:r>
+                    </a:p>
+                  </a:txBody>
+                  <a:tcPr/>
+                </a:tc>
+                <a:tc>
+                  <a:txBody>
+                    <a:bodyPr/>
+                    <a:lstStyle/>
+                    <a:p>
+                      <a:r>
+                        <a:rPr lang="en-US" sz="2400" dirty="0">
+                          <a:latin typeface="Garamond" panose="02020404030301010803" pitchFamily="18" charset="0"/>
+                        </a:rPr>
+                        <a:t>179</a:t>
+                      </a:r>
+                    </a:p>
+                  </a:txBody>
+                  <a:tcPr/>
+                </a:tc>
+                <a:extLst>
+                  <a:ext uri="{0D108BD9-81ED-4DB2-BD59-A6C34878D82A}">
+                    <a16:rowId xmlns:a16="http://schemas.microsoft.com/office/drawing/2014/main" val="589438565"/>
+                  </a:ext>
+                </a:extLst>
+              </a:tr>
+            </a:tbl>
+          </a:graphicData>
+        </a:graphic>
+      </p:graphicFrame>
+      <p:sp>
+        <p:nvSpPr>
+          <p:cNvPr id="8" name="TextBox 7">
+            <a:extLst>
+              <a:ext uri="{FF2B5EF4-FFF2-40B4-BE49-F238E27FC236}">
+                <a16:creationId xmlns:a16="http://schemas.microsoft.com/office/drawing/2014/main" id="{DB45042A-E97D-2A5E-8976-F4A1B3DD2EB0}"/>
+              </a:ext>
+            </a:extLst>
+          </p:cNvPr>
+          <p:cNvSpPr txBox="1"/>
+          <p:nvPr/>
+        </p:nvSpPr>
+        <p:spPr>
+          <a:xfrm>
+            <a:off x="126999" y="4448411"/>
+            <a:ext cx="5191621" cy="1639103"/>
+          </a:xfrm>
+          <a:prstGeom prst="rect">
+            <a:avLst/>
+          </a:prstGeom>
+          <a:noFill/>
+        </p:spPr>
+        <p:txBody>
+          <a:bodyPr wrap="square">
+            <a:spAutoFit/>
+          </a:bodyPr>
+          <a:lstStyle/>
+          <a:p>
+            <a:pPr algn="just" latinLnBrk="1"/>
+            <a:r>
+              <a:rPr lang="en-US" sz="1400" b="1" kern="100" dirty="0">
+                <a:latin typeface="Garamond" panose="02020404030301010803" pitchFamily="18" charset="0"/>
+                <a:ea typeface="Calibri" panose="020F0502020204030204" pitchFamily="34" charset="0"/>
+                <a:cs typeface="Times New Roman" panose="02020603050405020304" pitchFamily="18" charset="0"/>
+              </a:rPr>
+              <a:t>OUTPUT</a:t>
+            </a:r>
+            <a:r>
+              <a:rPr lang="en-US" sz="1400" kern="100" dirty="0">
+                <a:latin typeface="Garamond" panose="02020404030301010803" pitchFamily="18" charset="0"/>
+                <a:ea typeface="Calibri" panose="020F0502020204030204" pitchFamily="34" charset="0"/>
+                <a:cs typeface="Times New Roman" panose="02020603050405020304" pitchFamily="18" charset="0"/>
+              </a:rPr>
+              <a:t>:</a:t>
+            </a:r>
+            <a:br>
+              <a:rPr lang="en-US" sz="1400" kern="100" dirty="0">
+                <a:latin typeface="Garamond" panose="02020404030301010803" pitchFamily="18" charset="0"/>
+                <a:ea typeface="Calibri" panose="020F0502020204030204" pitchFamily="34" charset="0"/>
+                <a:cs typeface="Times New Roman" panose="02020603050405020304" pitchFamily="18" charset="0"/>
+              </a:rPr>
+            </a:br>
+            <a:r>
+              <a:rPr lang="en-US" dirty="0">
+                <a:latin typeface="Garamond" panose="02020404030301010803" pitchFamily="18" charset="0"/>
+              </a:rPr>
+              <a:t>The decision tree catches the most fires (86.5%) but has the highest false alarm rate (105). It has the best AUC (0.701), making it the strongest model for distinguishing fire from no-fire conditions.</a:t>
+            </a:r>
+          </a:p>
+          <a:p>
+            <a:pPr marL="0" marR="0">
+              <a:lnSpc>
+                <a:spcPct val="107000"/>
+              </a:lnSpc>
+              <a:spcBef>
+                <a:spcPts val="0"/>
+              </a:spcBef>
+              <a:spcAft>
+                <a:spcPts val="800"/>
+              </a:spcAft>
+            </a:pPr>
             <a:endParaRPr lang="en-US" sz="1400" kern="100" dirty="0">
               <a:effectLst/>
               <a:latin typeface="Garamond" panose="02020404030301010803" pitchFamily="18" charset="0"/>
@@ -23034,10 +23950,46 @@
           </a:p>
         </p:txBody>
       </p:sp>
+      <p:pic>
+        <p:nvPicPr>
+          <p:cNvPr id="10" name="Picture 9">
+            <a:extLst>
+              <a:ext uri="{FF2B5EF4-FFF2-40B4-BE49-F238E27FC236}">
+                <a16:creationId xmlns:a16="http://schemas.microsoft.com/office/drawing/2014/main" id="{7DBCE8B1-3674-A31C-12BA-3F7329E4571F}"/>
+              </a:ext>
+            </a:extLst>
+          </p:cNvPr>
+          <p:cNvPicPr>
+            <a:picLocks noChangeAspect="1"/>
+          </p:cNvPicPr>
+          <p:nvPr/>
+        </p:nvPicPr>
+        <p:blipFill>
+          <a:blip r:embed="rId2">
+            <a:extLst>
+              <a:ext uri="{28A0092B-C50C-407E-A947-70E740481C1C}">
+                <a14:useLocalDpi xmlns:a14="http://schemas.microsoft.com/office/drawing/2010/main" val="0"/>
+              </a:ext>
+            </a:extLst>
+          </a:blip>
+          <a:stretch>
+            <a:fillRect/>
+          </a:stretch>
+        </p:blipFill>
+        <p:spPr>
+          <a:xfrm>
+            <a:off x="6096000" y="2134872"/>
+            <a:ext cx="5103339" cy="4585798"/>
+          </a:xfrm>
+          <a:prstGeom prst="rect">
+            <a:avLst/>
+          </a:prstGeom>
+        </p:spPr>
+      </p:pic>
     </p:spTree>
     <p:extLst>
       <p:ext uri="{BB962C8B-B14F-4D97-AF65-F5344CB8AC3E}">
-        <p14:creationId xmlns:p14="http://schemas.microsoft.com/office/powerpoint/2010/main" val="2431895255"/>
+        <p14:creationId xmlns:p14="http://schemas.microsoft.com/office/powerpoint/2010/main" val="2556739444"/>
       </p:ext>
     </p:extLst>
   </p:cSld>
@@ -23047,7 +23999,108 @@
 </p:sld>
 </file>
 
-<file path=ppt/slides/slide6.xml><?xml version="1.0" encoding="utf-8"?>
+<file path=ppt/slides/slide7.xml><?xml version="1.0" encoding="utf-8"?>
+<p:sld xmlns:a="http://schemas.openxmlformats.org/drawingml/2006/main" xmlns:r="http://schemas.openxmlformats.org/officeDocument/2006/relationships" xmlns:p="http://schemas.openxmlformats.org/presentationml/2006/main">
+  <p:cSld>
+    <p:spTree>
+      <p:nvGrpSpPr>
+        <p:cNvPr id="1" name=""/>
+        <p:cNvGrpSpPr/>
+        <p:nvPr/>
+      </p:nvGrpSpPr>
+      <p:grpSpPr>
+        <a:xfrm>
+          <a:off x="0" y="0"/>
+          <a:ext cx="0" cy="0"/>
+          <a:chOff x="0" y="0"/>
+          <a:chExt cx="0" cy="0"/>
+        </a:xfrm>
+      </p:grpSpPr>
+      <p:sp>
+        <p:nvSpPr>
+          <p:cNvPr id="2" name="Title 1">
+            <a:extLst>
+              <a:ext uri="{FF2B5EF4-FFF2-40B4-BE49-F238E27FC236}">
+                <a16:creationId xmlns:a16="http://schemas.microsoft.com/office/drawing/2014/main" id="{01E53E8A-884D-91E2-41D5-74403C1214DE}"/>
+              </a:ext>
+            </a:extLst>
+          </p:cNvPr>
+          <p:cNvSpPr>
+            <a:spLocks noGrp="1"/>
+          </p:cNvSpPr>
+          <p:nvPr>
+            <p:ph type="title"/>
+          </p:nvPr>
+        </p:nvSpPr>
+        <p:spPr>
+          <a:xfrm>
+            <a:off x="2120587" y="533400"/>
+            <a:ext cx="7950825" cy="1270000"/>
+          </a:xfrm>
+        </p:spPr>
+        <p:txBody>
+          <a:bodyPr/>
+          <a:lstStyle/>
+          <a:p>
+            <a:r>
+              <a:rPr lang="en-US" dirty="0">
+                <a:latin typeface="Garamond" panose="02020404030301010803" pitchFamily="18" charset="0"/>
+              </a:rPr>
+              <a:t>PREDICTING DECISION TREE OUTCOME</a:t>
+            </a:r>
+          </a:p>
+        </p:txBody>
+      </p:sp>
+      <p:pic>
+        <p:nvPicPr>
+          <p:cNvPr id="7" name="Content Placeholder 6">
+            <a:extLst>
+              <a:ext uri="{FF2B5EF4-FFF2-40B4-BE49-F238E27FC236}">
+                <a16:creationId xmlns:a16="http://schemas.microsoft.com/office/drawing/2014/main" id="{70E7C87F-C707-098F-28AE-952781AFEC77}"/>
+              </a:ext>
+            </a:extLst>
+          </p:cNvPr>
+          <p:cNvPicPr>
+            <a:picLocks noGrp="1" noChangeAspect="1"/>
+          </p:cNvPicPr>
+          <p:nvPr>
+            <p:ph sz="quarter" idx="13"/>
+          </p:nvPr>
+        </p:nvPicPr>
+        <p:blipFill>
+          <a:blip r:embed="rId2">
+            <a:extLst>
+              <a:ext uri="{28A0092B-C50C-407E-A947-70E740481C1C}">
+                <a14:useLocalDpi xmlns:a14="http://schemas.microsoft.com/office/drawing/2010/main" val="0"/>
+              </a:ext>
+            </a:extLst>
+          </a:blip>
+          <a:srcRect t="10945"/>
+          <a:stretch>
+            <a:fillRect/>
+          </a:stretch>
+        </p:blipFill>
+        <p:spPr>
+          <a:xfrm>
+            <a:off x="830509" y="1728133"/>
+            <a:ext cx="10628851" cy="5050172"/>
+          </a:xfrm>
+        </p:spPr>
+      </p:pic>
+    </p:spTree>
+    <p:extLst>
+      <p:ext uri="{BB962C8B-B14F-4D97-AF65-F5344CB8AC3E}">
+        <p14:creationId xmlns:p14="http://schemas.microsoft.com/office/powerpoint/2010/main" val="1766755720"/>
+      </p:ext>
+    </p:extLst>
+  </p:cSld>
+  <p:clrMapOvr>
+    <a:masterClrMapping/>
+  </p:clrMapOvr>
+</p:sld>
+</file>
+
+<file path=ppt/slides/slide8.xml><?xml version="1.0" encoding="utf-8"?>
 <p:sld xmlns:a="http://schemas.openxmlformats.org/drawingml/2006/main" xmlns:r="http://schemas.openxmlformats.org/officeDocument/2006/relationships" xmlns:p="http://schemas.openxmlformats.org/presentationml/2006/main">
   <p:cSld>
     <p:spTree>
@@ -23117,7 +24170,7 @@
               <a:rPr lang="en-US" b="1" dirty="0">
                 <a:latin typeface="Garamond" panose="02020404030301010803" pitchFamily="18" charset="0"/>
               </a:rPr>
-              <a:t>Linear regression</a:t>
+              <a:t>RANDOM FOREST regression</a:t>
             </a:r>
             <a:br>
               <a:rPr lang="en-US" dirty="0"/>
@@ -23147,17 +24200,28 @@
         </p:nvSpPr>
         <p:spPr>
           <a:xfrm>
-            <a:off x="6096000" y="609600"/>
-            <a:ext cx="5842000" cy="5791200"/>
+            <a:off x="144943" y="4169328"/>
+            <a:ext cx="5660239" cy="1543575"/>
           </a:xfrm>
         </p:spPr>
         <p:txBody>
-          <a:bodyPr/>
+          <a:bodyPr>
+            <a:normAutofit fontScale="92500" lnSpcReduction="10000"/>
+          </a:bodyPr>
           <a:lstStyle/>
           <a:p>
-            <a:pPr marL="0" indent="0">
+            <a:pPr marL="0" indent="0" algn="ctr">
               <a:buNone/>
             </a:pPr>
+            <a:r>
+              <a:rPr lang="en-US" sz="1800" b="1" kern="100" dirty="0">
+                <a:effectLst/>
+                <a:latin typeface="Garamond" panose="02020404030301010803" pitchFamily="18" charset="0"/>
+                <a:ea typeface="Calibri" panose="020F0502020204030204" pitchFamily="34" charset="0"/>
+                <a:cs typeface="Times New Roman" panose="02020603050405020304" pitchFamily="18" charset="0"/>
+              </a:rPr>
+              <a:t>OUTPUT: </a:t>
+            </a:r>
             <a:endParaRPr lang="en-US" sz="1800" kern="100" dirty="0">
               <a:effectLst/>
               <a:latin typeface="Garamond" panose="02020404030301010803" pitchFamily="18" charset="0"/>
@@ -23166,14 +24230,13 @@
             </a:endParaRPr>
           </a:p>
           <a:p>
-            <a:pPr marL="0" indent="0">
-              <a:buNone/>
-            </a:pPr>
-            <a:endParaRPr lang="en-US" sz="1800" kern="100" dirty="0">
-              <a:latin typeface="Garamond" panose="02020404030301010803" pitchFamily="18" charset="0"/>
-              <a:ea typeface="Calibri" panose="020F0502020204030204" pitchFamily="34" charset="0"/>
-              <a:cs typeface="Times New Roman" panose="02020603050405020304" pitchFamily="18" charset="0"/>
-            </a:endParaRPr>
+            <a:pPr latinLnBrk="1"/>
+            <a:r>
+              <a:rPr lang="en-US" dirty="0">
+                <a:latin typeface="Garamond" panose="02020404030301010803" pitchFamily="18" charset="0"/>
+              </a:rPr>
+              <a:t>The random forest has the lowest false alarm rate (74) and the highest specificity (54.0%). However, it catches the fewest fires (69.6%). Best when avoiding false alarms is the priority.</a:t>
+            </a:r>
           </a:p>
           <a:p>
             <a:pPr marL="0" indent="0" algn="just">
@@ -23184,35 +24247,6 @@
               <a:latin typeface="Garamond" panose="02020404030301010803" pitchFamily="18" charset="0"/>
               <a:ea typeface="Calibri" panose="020F0502020204030204" pitchFamily="34" charset="0"/>
               <a:cs typeface="Times New Roman" panose="02020603050405020304" pitchFamily="18" charset="0"/>
-            </a:endParaRPr>
-          </a:p>
-          <a:p>
-            <a:pPr marL="0" indent="0" algn="just">
-              <a:buNone/>
-            </a:pPr>
-            <a:endParaRPr lang="en-US" sz="1800" kern="100" dirty="0">
-              <a:latin typeface="Garamond" panose="02020404030301010803" pitchFamily="18" charset="0"/>
-              <a:ea typeface="Calibri" panose="020F0502020204030204" pitchFamily="34" charset="0"/>
-              <a:cs typeface="Times New Roman" panose="02020603050405020304" pitchFamily="18" charset="0"/>
-            </a:endParaRPr>
-          </a:p>
-          <a:p>
-            <a:pPr marL="0" indent="0" algn="just">
-              <a:buNone/>
-            </a:pPr>
-            <a:r>
-              <a:rPr lang="en-US" sz="1800" kern="100" dirty="0">
-                <a:effectLst/>
-                <a:latin typeface="Garamond" panose="02020404030301010803" pitchFamily="18" charset="0"/>
-                <a:ea typeface="Calibri" panose="020F0502020204030204" pitchFamily="34" charset="0"/>
-                <a:cs typeface="Times New Roman" panose="02020603050405020304" pitchFamily="18" charset="0"/>
-              </a:rPr>
-              <a:t>The linear regression model shows a moderate level of prediction error and explains a very small proportion of the variance in fire occurrence. This suggests that the model might be underfitting and not capturing the underlying patterns in the data well.</a:t>
-            </a:r>
-          </a:p>
-          <a:p>
-            <a:endParaRPr lang="en-US" dirty="0">
-              <a:latin typeface="Garamond" panose="02020404030301010803" pitchFamily="18" charset="0"/>
             </a:endParaRPr>
           </a:p>
         </p:txBody>
@@ -23236,7 +24270,7 @@
         <p:spPr>
           <a:xfrm>
             <a:off x="254000" y="2057400"/>
-            <a:ext cx="5537200" cy="4572000"/>
+            <a:ext cx="4680309" cy="2111928"/>
           </a:xfrm>
         </p:spPr>
         <p:txBody>
@@ -23245,244 +24279,7 @@
           </a:bodyPr>
           <a:lstStyle/>
           <a:p>
-            <a:r>
-              <a:rPr lang="en-US" sz="2800" b="1" dirty="0">
-                <a:latin typeface="Garamond" panose="02020404030301010803" pitchFamily="18" charset="0"/>
-              </a:rPr>
-              <a:t>Performance matrix result</a:t>
-            </a:r>
-          </a:p>
-          <a:p>
-            <a:endParaRPr lang="en-US" sz="2800" b="1" dirty="0">
-              <a:latin typeface="Garamond" panose="02020404030301010803" pitchFamily="18" charset="0"/>
-            </a:endParaRPr>
-          </a:p>
-          <a:p>
-            <a:pPr marL="342900" marR="0" lvl="0" indent="-342900" algn="just">
-              <a:lnSpc>
-                <a:spcPct val="107000"/>
-              </a:lnSpc>
-              <a:spcBef>
-                <a:spcPts val="0"/>
-              </a:spcBef>
-              <a:spcAft>
-                <a:spcPts val="800"/>
-              </a:spcAft>
-              <a:buSzPts val="1000"/>
-              <a:buFont typeface="Symbol" panose="05050102010706020507" pitchFamily="18" charset="2"/>
-              <a:buChar char=""/>
-              <a:tabLst>
-                <a:tab pos="457200" algn="l"/>
-              </a:tabLst>
-            </a:pPr>
-            <a:r>
-              <a:rPr lang="en-US" sz="1800" b="1" kern="100" dirty="0">
-                <a:effectLst/>
-                <a:latin typeface="Garamond" panose="02020404030301010803" pitchFamily="18" charset="0"/>
-                <a:ea typeface="Calibri" panose="020F0502020204030204" pitchFamily="34" charset="0"/>
-                <a:cs typeface="Times New Roman" panose="02020603050405020304" pitchFamily="18" charset="0"/>
-              </a:rPr>
-              <a:t>RMSE:</a:t>
-            </a:r>
-            <a:r>
-              <a:rPr lang="en-US" sz="1800" kern="100" dirty="0">
-                <a:effectLst/>
-                <a:latin typeface="Garamond" panose="02020404030301010803" pitchFamily="18" charset="0"/>
-                <a:ea typeface="Calibri" panose="020F0502020204030204" pitchFamily="34" charset="0"/>
-                <a:cs typeface="Times New Roman" panose="02020603050405020304" pitchFamily="18" charset="0"/>
-              </a:rPr>
-              <a:t> 0.585 (The root mean square error indicates the average difference between the predicted and actual values)</a:t>
-            </a:r>
-          </a:p>
-          <a:p>
-            <a:pPr marL="342900" marR="0" lvl="0" indent="-342900" algn="just">
-              <a:lnSpc>
-                <a:spcPct val="107000"/>
-              </a:lnSpc>
-              <a:spcBef>
-                <a:spcPts val="0"/>
-              </a:spcBef>
-              <a:spcAft>
-                <a:spcPts val="800"/>
-              </a:spcAft>
-              <a:buSzPts val="1000"/>
-              <a:buFont typeface="Symbol" panose="05050102010706020507" pitchFamily="18" charset="2"/>
-              <a:buChar char=""/>
-              <a:tabLst>
-                <a:tab pos="457200" algn="l"/>
-              </a:tabLst>
-            </a:pPr>
-            <a:r>
-              <a:rPr lang="en-US" sz="1800" b="1" kern="100" dirty="0">
-                <a:effectLst/>
-                <a:latin typeface="Garamond" panose="02020404030301010803" pitchFamily="18" charset="0"/>
-                <a:ea typeface="Calibri" panose="020F0502020204030204" pitchFamily="34" charset="0"/>
-                <a:cs typeface="Times New Roman" panose="02020603050405020304" pitchFamily="18" charset="0"/>
-              </a:rPr>
-              <a:t>R-Squared:</a:t>
-            </a:r>
-            <a:r>
-              <a:rPr lang="en-US" sz="1800" kern="100" dirty="0">
-                <a:effectLst/>
-                <a:latin typeface="Garamond" panose="02020404030301010803" pitchFamily="18" charset="0"/>
-                <a:ea typeface="Calibri" panose="020F0502020204030204" pitchFamily="34" charset="0"/>
-                <a:cs typeface="Times New Roman" panose="02020603050405020304" pitchFamily="18" charset="0"/>
-              </a:rPr>
-              <a:t> 0.0851 (8.51% of the variance in the fire occurrence can be explained by the model)</a:t>
-            </a:r>
-          </a:p>
-          <a:p>
-            <a:endParaRPr lang="en-US" dirty="0"/>
-          </a:p>
-        </p:txBody>
-      </p:sp>
-    </p:spTree>
-    <p:extLst>
-      <p:ext uri="{BB962C8B-B14F-4D97-AF65-F5344CB8AC3E}">
-        <p14:creationId xmlns:p14="http://schemas.microsoft.com/office/powerpoint/2010/main" val="3765150085"/>
-      </p:ext>
-    </p:extLst>
-  </p:cSld>
-  <p:clrMapOvr>
-    <a:masterClrMapping/>
-  </p:clrMapOvr>
-</p:sld>
-</file>
-
-<file path=ppt/slides/slide7.xml><?xml version="1.0" encoding="utf-8"?>
-<p:sld xmlns:a="http://schemas.openxmlformats.org/drawingml/2006/main" xmlns:r="http://schemas.openxmlformats.org/officeDocument/2006/relationships" xmlns:p="http://schemas.openxmlformats.org/presentationml/2006/main">
-  <p:cSld>
-    <p:spTree>
-      <p:nvGrpSpPr>
-        <p:cNvPr id="1" name=""/>
-        <p:cNvGrpSpPr/>
-        <p:nvPr/>
-      </p:nvGrpSpPr>
-      <p:grpSpPr>
-        <a:xfrm>
-          <a:off x="0" y="0"/>
-          <a:ext cx="0" cy="0"/>
-          <a:chOff x="0" y="0"/>
-          <a:chExt cx="0" cy="0"/>
-        </a:xfrm>
-      </p:grpSpPr>
-      <p:sp>
-        <p:nvSpPr>
-          <p:cNvPr id="2" name="Title 1">
-            <a:extLst>
-              <a:ext uri="{FF2B5EF4-FFF2-40B4-BE49-F238E27FC236}">
-                <a16:creationId xmlns:a16="http://schemas.microsoft.com/office/drawing/2014/main" id="{FD571192-1759-0360-10E9-454E61B49FBD}"/>
-              </a:ext>
-            </a:extLst>
-          </p:cNvPr>
-          <p:cNvSpPr>
-            <a:spLocks noGrp="1"/>
-          </p:cNvSpPr>
-          <p:nvPr>
-            <p:ph type="title"/>
-          </p:nvPr>
-        </p:nvSpPr>
-        <p:spPr>
-          <a:xfrm>
-            <a:off x="745995" y="1326093"/>
-            <a:ext cx="3935688" cy="1121538"/>
-          </a:xfrm>
-        </p:spPr>
-        <p:txBody>
-          <a:bodyPr>
-            <a:normAutofit fontScale="90000"/>
-          </a:bodyPr>
-          <a:lstStyle/>
-          <a:p>
-            <a:r>
-              <a:rPr lang="en-US" b="1" dirty="0">
-                <a:latin typeface="Garamond" panose="02020404030301010803" pitchFamily="18" charset="0"/>
-              </a:rPr>
-              <a:t>Decision tree regression</a:t>
-            </a:r>
-            <a:br>
-              <a:rPr lang="en-US" dirty="0">
-                <a:latin typeface="Garamond" panose="02020404030301010803" pitchFamily="18" charset="0"/>
-              </a:rPr>
-            </a:br>
-            <a:br>
-              <a:rPr lang="en-US" dirty="0">
-                <a:latin typeface="Garamond" panose="02020404030301010803" pitchFamily="18" charset="0"/>
-              </a:rPr>
-            </a:br>
-            <a:endParaRPr lang="en-US" dirty="0">
-              <a:latin typeface="Garamond" panose="02020404030301010803" pitchFamily="18" charset="0"/>
-            </a:endParaRPr>
-          </a:p>
-        </p:txBody>
-      </p:sp>
-      <p:pic>
-        <p:nvPicPr>
-          <p:cNvPr id="6" name="Content Placeholder 5">
-            <a:extLst>
-              <a:ext uri="{FF2B5EF4-FFF2-40B4-BE49-F238E27FC236}">
-                <a16:creationId xmlns:a16="http://schemas.microsoft.com/office/drawing/2014/main" id="{28308044-F6B5-846A-3805-41EDDF6EFBAF}"/>
-              </a:ext>
-            </a:extLst>
-          </p:cNvPr>
-          <p:cNvPicPr>
-            <a:picLocks noGrp="1" noChangeAspect="1"/>
-          </p:cNvPicPr>
-          <p:nvPr>
-            <p:ph sz="quarter" idx="13"/>
-          </p:nvPr>
-        </p:nvPicPr>
-        <p:blipFill>
-          <a:blip r:embed="rId2">
-            <a:extLst>
-              <a:ext uri="{28A0092B-C50C-407E-A947-70E740481C1C}">
-                <a14:useLocalDpi xmlns:a14="http://schemas.microsoft.com/office/drawing/2010/main" val="0"/>
-              </a:ext>
-            </a:extLst>
-          </a:blip>
-          <a:stretch>
-            <a:fillRect/>
-          </a:stretch>
-        </p:blipFill>
-        <p:spPr>
-          <a:xfrm>
-            <a:off x="5226341" y="2447631"/>
-            <a:ext cx="6420375" cy="4062226"/>
-          </a:xfrm>
-          <a:prstGeom prst="rect">
-            <a:avLst/>
-          </a:prstGeom>
-        </p:spPr>
-      </p:pic>
-      <p:sp>
-        <p:nvSpPr>
-          <p:cNvPr id="4" name="Text Placeholder 3">
-            <a:extLst>
-              <a:ext uri="{FF2B5EF4-FFF2-40B4-BE49-F238E27FC236}">
-                <a16:creationId xmlns:a16="http://schemas.microsoft.com/office/drawing/2014/main" id="{522E5C78-4CBC-3C1F-AD75-A719E7032835}"/>
-              </a:ext>
-            </a:extLst>
-          </p:cNvPr>
-          <p:cNvSpPr>
-            <a:spLocks noGrp="1"/>
-          </p:cNvSpPr>
-          <p:nvPr>
-            <p:ph type="body" sz="half" idx="2"/>
-          </p:nvPr>
-        </p:nvSpPr>
-        <p:spPr>
-          <a:xfrm>
-            <a:off x="253998" y="1699261"/>
-            <a:ext cx="4595463" cy="2971800"/>
-          </a:xfrm>
-        </p:spPr>
-        <p:txBody>
-          <a:bodyPr>
-            <a:normAutofit fontScale="92500" lnSpcReduction="10000"/>
-          </a:bodyPr>
-          <a:lstStyle/>
-          <a:p>
-            <a:pPr marL="0" marR="0" algn="just">
+            <a:pPr algn="just">
               <a:lnSpc>
                 <a:spcPct val="107000"/>
               </a:lnSpc>
@@ -23494,24 +24291,14 @@
               </a:spcAft>
             </a:pPr>
             <a:r>
-              <a:rPr lang="en-US" sz="1800" b="1" kern="100" dirty="0">
-                <a:effectLst/>
+              <a:rPr lang="en-US" b="1" kern="100" dirty="0">
                 <a:latin typeface="Garamond" panose="02020404030301010803" pitchFamily="18" charset="0"/>
                 <a:ea typeface="Calibri" panose="020F0502020204030204" pitchFamily="34" charset="0"/>
                 <a:cs typeface="Times New Roman" panose="02020603050405020304" pitchFamily="18" charset="0"/>
               </a:rPr>
-              <a:t>Performance metrics</a:t>
+              <a:t>Performance metrics result</a:t>
             </a:r>
-            <a:r>
-              <a:rPr lang="en-US" sz="1800" b="1" kern="100" dirty="0">
-                <a:latin typeface="Garamond" panose="02020404030301010803" pitchFamily="18" charset="0"/>
-                <a:ea typeface="Calibri" panose="020F0502020204030204" pitchFamily="34" charset="0"/>
-                <a:cs typeface="Times New Roman" panose="02020603050405020304" pitchFamily="18" charset="0"/>
-              </a:rPr>
-              <a:t> result</a:t>
-            </a:r>
-            <a:endParaRPr lang="en-US" sz="1800" kern="100" dirty="0">
-              <a:effectLst/>
+            <a:endParaRPr lang="en-US" kern="100" dirty="0">
               <a:latin typeface="Garamond" panose="02020404030301010803" pitchFamily="18" charset="0"/>
               <a:ea typeface="Calibri" panose="020F0502020204030204" pitchFamily="34" charset="0"/>
               <a:cs typeface="Times New Roman" panose="02020603050405020304" pitchFamily="18" charset="0"/>
@@ -23536,22 +24323,20 @@
               </a:tabLst>
             </a:pPr>
             <a:r>
-              <a:rPr lang="en-US" sz="1800" b="1" kern="100" dirty="0">
-                <a:effectLst/>
+              <a:rPr lang="en-US" b="1" kern="100" dirty="0">
                 <a:latin typeface="Garamond" panose="02020404030301010803" pitchFamily="18" charset="0"/>
                 <a:ea typeface="Calibri" panose="020F0502020204030204" pitchFamily="34" charset="0"/>
                 <a:cs typeface="Times New Roman" panose="02020603050405020304" pitchFamily="18" charset="0"/>
               </a:rPr>
-              <a:t>Accuracy:</a:t>
+              <a:t>Accuracy: </a:t>
             </a:r>
             <a:r>
-              <a:rPr lang="en-US" sz="1800" kern="100" dirty="0">
-                <a:effectLst/>
+              <a:rPr lang="en-US" kern="100" dirty="0">
                 <a:latin typeface="Garamond" panose="02020404030301010803" pitchFamily="18" charset="0"/>
                 <a:ea typeface="Calibri" panose="020F0502020204030204" pitchFamily="34" charset="0"/>
                 <a:cs typeface="Times New Roman" panose="02020603050405020304" pitchFamily="18" charset="0"/>
               </a:rPr>
-              <a:t> 0.587 (58.7% of predictions are correct)</a:t>
+              <a:t>62.8%</a:t>
             </a:r>
           </a:p>
           <a:p>
@@ -23573,22 +24358,20 @@
               </a:tabLst>
             </a:pPr>
             <a:r>
-              <a:rPr lang="en-US" sz="1800" b="1" kern="100" dirty="0">
-                <a:effectLst/>
+              <a:rPr lang="en-US" b="1" kern="100" dirty="0">
                 <a:latin typeface="Garamond" panose="02020404030301010803" pitchFamily="18" charset="0"/>
                 <a:ea typeface="Calibri" panose="020F0502020204030204" pitchFamily="34" charset="0"/>
                 <a:cs typeface="Times New Roman" panose="02020603050405020304" pitchFamily="18" charset="0"/>
               </a:rPr>
-              <a:t>Sensitivity (Recall):</a:t>
+              <a:t>Sensitivity (Recall): </a:t>
             </a:r>
             <a:r>
-              <a:rPr lang="en-US" sz="1800" kern="100" dirty="0">
-                <a:effectLst/>
+              <a:rPr lang="en-US" kern="100" dirty="0">
                 <a:latin typeface="Garamond" panose="02020404030301010803" pitchFamily="18" charset="0"/>
                 <a:ea typeface="Calibri" panose="020F0502020204030204" pitchFamily="34" charset="0"/>
                 <a:cs typeface="Times New Roman" panose="02020603050405020304" pitchFamily="18" charset="0"/>
               </a:rPr>
-              <a:t> 0.379 (37.9% of actual fires are correctly identified)</a:t>
+              <a:t>69.6% </a:t>
             </a:r>
           </a:p>
           <a:p>
@@ -23610,8 +24393,7 @@
               </a:tabLst>
             </a:pPr>
             <a:r>
-              <a:rPr lang="en-US" sz="1800" b="1" kern="100" dirty="0">
-                <a:effectLst/>
+              <a:rPr lang="en-US" b="1" kern="100" dirty="0">
                 <a:latin typeface="Garamond" panose="02020404030301010803" pitchFamily="18" charset="0"/>
                 <a:ea typeface="Calibri" panose="020F0502020204030204" pitchFamily="34" charset="0"/>
                 <a:cs typeface="Times New Roman" panose="02020603050405020304" pitchFamily="18" charset="0"/>
@@ -23619,13 +24401,12 @@
               <a:t>Specificity:</a:t>
             </a:r>
             <a:r>
-              <a:rPr lang="en-US" sz="1800" kern="100" dirty="0">
-                <a:effectLst/>
+              <a:rPr lang="en-US" kern="100" dirty="0">
                 <a:latin typeface="Garamond" panose="02020404030301010803" pitchFamily="18" charset="0"/>
                 <a:ea typeface="Calibri" panose="020F0502020204030204" pitchFamily="34" charset="0"/>
                 <a:cs typeface="Times New Roman" panose="02020603050405020304" pitchFamily="18" charset="0"/>
               </a:rPr>
-              <a:t> 0.749 (74.9% of non-fire days are correctly identified)</a:t>
+              <a:t> 54%</a:t>
             </a:r>
           </a:p>
           <a:p>
@@ -23647,28 +24428,21 @@
               </a:tabLst>
             </a:pPr>
             <a:r>
-              <a:rPr lang="en-US" sz="1800" b="1" kern="100" dirty="0">
-                <a:effectLst/>
+              <a:rPr lang="en-US" b="1" kern="100" dirty="0">
                 <a:latin typeface="Garamond" panose="02020404030301010803" pitchFamily="18" charset="0"/>
                 <a:ea typeface="Calibri" panose="020F0502020204030204" pitchFamily="34" charset="0"/>
                 <a:cs typeface="Times New Roman" panose="02020603050405020304" pitchFamily="18" charset="0"/>
               </a:rPr>
-              <a:t>ROC AUC:</a:t>
+              <a:t>ROC AUC: </a:t>
             </a:r>
             <a:r>
-              <a:rPr lang="en-US" sz="1800" kern="100" dirty="0">
-                <a:effectLst/>
+              <a:rPr lang="en-US" kern="100" dirty="0">
                 <a:latin typeface="Garamond" panose="02020404030301010803" pitchFamily="18" charset="0"/>
                 <a:ea typeface="Calibri" panose="020F0502020204030204" pitchFamily="34" charset="0"/>
                 <a:cs typeface="Times New Roman" panose="02020603050405020304" pitchFamily="18" charset="0"/>
               </a:rPr>
-              <a:t> 0.554 (The model has limited discriminative power)</a:t>
+              <a:t>0.670</a:t>
             </a:r>
-          </a:p>
-          <a:p>
-            <a:endParaRPr lang="en-US" dirty="0">
-              <a:latin typeface="Garamond" panose="02020404030301010803" pitchFamily="18" charset="0"/>
-            </a:endParaRPr>
           </a:p>
         </p:txBody>
       </p:sp>
@@ -23677,7 +24451,7 @@
           <p:cNvPr id="5" name="Table 4">
             <a:extLst>
               <a:ext uri="{FF2B5EF4-FFF2-40B4-BE49-F238E27FC236}">
-                <a16:creationId xmlns:a16="http://schemas.microsoft.com/office/drawing/2014/main" id="{C5583441-D335-B28D-37B1-0AA82B897492}"/>
+                <a16:creationId xmlns:a16="http://schemas.microsoft.com/office/drawing/2014/main" id="{1539C282-7851-90DE-A750-1D7621E9950A}"/>
               </a:ext>
             </a:extLst>
           </p:cNvPr>
@@ -23687,14 +24461,14 @@
           <p:nvPr>
             <p:extLst>
               <p:ext uri="{D42A27DB-BD31-4B8C-83A1-F6EECF244321}">
-                <p14:modId xmlns:p14="http://schemas.microsoft.com/office/powerpoint/2010/main" val="3045395352"/>
+                <p14:modId xmlns:p14="http://schemas.microsoft.com/office/powerpoint/2010/main" val="3311559584"/>
               </p:ext>
             </p:extLst>
           </p:nvPr>
         </p:nvGraphicFramePr>
         <p:xfrm>
-          <a:off x="5079038" y="557532"/>
-          <a:ext cx="6629400" cy="1577340"/>
+          <a:off x="5612234" y="557532"/>
+          <a:ext cx="6096204" cy="1577340"/>
         </p:xfrm>
         <a:graphic>
           <a:graphicData uri="http://schemas.openxmlformats.org/drawingml/2006/table">
@@ -23703,21 +24477,21 @@
                 <a:tableStyleId>{5C22544A-7EE6-4342-B048-85BDC9FD1C3A}</a:tableStyleId>
               </a:tblPr>
               <a:tblGrid>
-                <a:gridCol w="2209800">
+                <a:gridCol w="2032068">
                   <a:extLst>
                     <a:ext uri="{9D8B030D-6E8A-4147-A177-3AD203B41FA5}">
                       <a16:colId xmlns:a16="http://schemas.microsoft.com/office/drawing/2014/main" val="3601434795"/>
                     </a:ext>
                   </a:extLst>
                 </a:gridCol>
-                <a:gridCol w="2209800">
+                <a:gridCol w="2032068">
                   <a:extLst>
                     <a:ext uri="{9D8B030D-6E8A-4147-A177-3AD203B41FA5}">
                       <a16:colId xmlns:a16="http://schemas.microsoft.com/office/drawing/2014/main" val="2054355883"/>
                     </a:ext>
                   </a:extLst>
                 </a:gridCol>
-                <a:gridCol w="2209800">
+                <a:gridCol w="2032068">
                   <a:extLst>
                     <a:ext uri="{9D8B030D-6E8A-4147-A177-3AD203B41FA5}">
                       <a16:colId xmlns:a16="http://schemas.microsoft.com/office/drawing/2014/main" val="2269804400"/>
@@ -23732,7 +24506,7 @@
                     <a:lstStyle/>
                     <a:p>
                       <a:r>
-                        <a:rPr lang="en-US" sz="2800" dirty="0">
+                        <a:rPr lang="en-US" sz="2400" dirty="0">
                           <a:latin typeface="Garamond" panose="02020404030301010803" pitchFamily="18" charset="0"/>
                         </a:rPr>
                         <a:t>Conf. Matrix</a:t>
@@ -23747,7 +24521,7 @@
                     <a:lstStyle/>
                     <a:p>
                       <a:r>
-                        <a:rPr lang="en-US" sz="2800" dirty="0">
+                        <a:rPr lang="en-US" sz="2400" dirty="0">
                           <a:latin typeface="Garamond" panose="02020404030301010803" pitchFamily="18" charset="0"/>
                         </a:rPr>
                         <a:t>POSITIVE</a:t>
@@ -23762,7 +24536,7 @@
                     <a:lstStyle/>
                     <a:p>
                       <a:r>
-                        <a:rPr lang="en-US" sz="2800" dirty="0">
+                        <a:rPr lang="en-US" sz="2400" dirty="0">
                           <a:latin typeface="Garamond" panose="02020404030301010803" pitchFamily="18" charset="0"/>
                         </a:rPr>
                         <a:t>NEGATIVE</a:t>
@@ -23784,7 +24558,7 @@
                     <a:lstStyle/>
                     <a:p>
                       <a:r>
-                        <a:rPr lang="en-US" sz="2800" dirty="0">
+                        <a:rPr lang="en-US" sz="2400" dirty="0">
                           <a:latin typeface="Garamond" panose="02020404030301010803" pitchFamily="18" charset="0"/>
                         </a:rPr>
                         <a:t>POSITIVE</a:t>
@@ -23799,10 +24573,10 @@
                     <a:lstStyle/>
                     <a:p>
                       <a:r>
-                        <a:rPr lang="en-US" sz="2800" dirty="0">
+                        <a:rPr lang="en-US" sz="2400" dirty="0">
                           <a:latin typeface="Garamond" panose="02020404030301010803" pitchFamily="18" charset="0"/>
                         </a:rPr>
-                        <a:t>155</a:t>
+                        <a:t>87</a:t>
                       </a:r>
                     </a:p>
                   </a:txBody>
@@ -23814,10 +24588,10 @@
                     <a:lstStyle/>
                     <a:p>
                       <a:r>
-                        <a:rPr lang="en-US" sz="2800" dirty="0">
+                        <a:rPr lang="en-US" sz="2400" dirty="0">
                           <a:latin typeface="Garamond" panose="02020404030301010803" pitchFamily="18" charset="0"/>
                         </a:rPr>
-                        <a:t>52</a:t>
+                        <a:t>63</a:t>
                       </a:r>
                     </a:p>
                   </a:txBody>
@@ -23836,7 +24610,7 @@
                     <a:lstStyle/>
                     <a:p>
                       <a:r>
-                        <a:rPr lang="en-US" sz="2800" dirty="0">
+                        <a:rPr lang="en-US" sz="2400" dirty="0">
                           <a:latin typeface="Garamond" panose="02020404030301010803" pitchFamily="18" charset="0"/>
                         </a:rPr>
                         <a:t>NEGATIVE</a:t>
@@ -23851,10 +24625,10 @@
                     <a:lstStyle/>
                     <a:p>
                       <a:r>
-                        <a:rPr lang="en-US" sz="2800" dirty="0">
+                        <a:rPr lang="en-US" sz="2400" dirty="0">
                           <a:latin typeface="Garamond" panose="02020404030301010803" pitchFamily="18" charset="0"/>
                         </a:rPr>
-                        <a:t>100</a:t>
+                        <a:t>74</a:t>
                       </a:r>
                     </a:p>
                   </a:txBody>
@@ -23866,10 +24640,10 @@
                     <a:lstStyle/>
                     <a:p>
                       <a:r>
-                        <a:rPr lang="en-US" sz="2800" dirty="0">
+                        <a:rPr lang="en-US" sz="2400" dirty="0">
                           <a:latin typeface="Garamond" panose="02020404030301010803" pitchFamily="18" charset="0"/>
                         </a:rPr>
-                        <a:t>61</a:t>
+                        <a:t>144</a:t>
                       </a:r>
                     </a:p>
                   </a:txBody>
@@ -23885,143 +24659,19 @@
           </a:graphicData>
         </a:graphic>
       </p:graphicFrame>
-      <p:sp>
-        <p:nvSpPr>
-          <p:cNvPr id="8" name="TextBox 7">
+      <p:pic>
+        <p:nvPicPr>
+          <p:cNvPr id="9" name="Picture 8">
             <a:extLst>
               <a:ext uri="{FF2B5EF4-FFF2-40B4-BE49-F238E27FC236}">
-                <a16:creationId xmlns:a16="http://schemas.microsoft.com/office/drawing/2014/main" id="{DB45042A-E97D-2A5E-8976-F4A1B3DD2EB0}"/>
-              </a:ext>
-            </a:extLst>
-          </p:cNvPr>
-          <p:cNvSpPr txBox="1"/>
-          <p:nvPr/>
-        </p:nvSpPr>
-        <p:spPr>
-          <a:xfrm>
-            <a:off x="126999" y="4448411"/>
-            <a:ext cx="4849463" cy="2152256"/>
-          </a:xfrm>
-          <a:prstGeom prst="rect">
-            <a:avLst/>
-          </a:prstGeom>
-          <a:noFill/>
-        </p:spPr>
-        <p:txBody>
-          <a:bodyPr wrap="square">
-            <a:spAutoFit/>
-          </a:bodyPr>
-          <a:lstStyle/>
-          <a:p>
-            <a:pPr marL="0" marR="0" algn="just">
-              <a:lnSpc>
-                <a:spcPct val="107000"/>
-              </a:lnSpc>
-              <a:spcBef>
-                <a:spcPts val="0"/>
-              </a:spcBef>
-              <a:spcAft>
-                <a:spcPts val="800"/>
-              </a:spcAft>
-            </a:pPr>
-            <a:r>
-              <a:rPr lang="en-US" sz="1800" kern="100" dirty="0">
-                <a:effectLst/>
-                <a:latin typeface="Garamond" panose="02020404030301010803" pitchFamily="18" charset="0"/>
-                <a:ea typeface="Calibri" panose="020F0502020204030204" pitchFamily="34" charset="0"/>
-                <a:cs typeface="Times New Roman" panose="02020603050405020304" pitchFamily="18" charset="0"/>
-              </a:rPr>
-              <a:t>The decision tree model outperforms logistic regression slightly in terms of accuracy and specificity. However, its sensitivity remains low, indicating a tendency to miss fire events. The ROC AUC value suggests the model's overall ability to distinguish between fire and no-fire events is still limited</a:t>
-            </a:r>
-            <a:endParaRPr lang="en-US" sz="1400" kern="100" dirty="0">
-              <a:effectLst/>
-              <a:latin typeface="Garamond" panose="02020404030301010803" pitchFamily="18" charset="0"/>
-              <a:ea typeface="Calibri" panose="020F0502020204030204" pitchFamily="34" charset="0"/>
-              <a:cs typeface="Times New Roman" panose="02020603050405020304" pitchFamily="18" charset="0"/>
-            </a:endParaRPr>
-          </a:p>
-        </p:txBody>
-      </p:sp>
-    </p:spTree>
-    <p:extLst>
-      <p:ext uri="{BB962C8B-B14F-4D97-AF65-F5344CB8AC3E}">
-        <p14:creationId xmlns:p14="http://schemas.microsoft.com/office/powerpoint/2010/main" val="2556739444"/>
-      </p:ext>
-    </p:extLst>
-  </p:cSld>
-  <p:clrMapOvr>
-    <a:masterClrMapping/>
-  </p:clrMapOvr>
-</p:sld>
-</file>
-
-<file path=ppt/slides/slide8.xml><?xml version="1.0" encoding="utf-8"?>
-<p:sld xmlns:a="http://schemas.openxmlformats.org/drawingml/2006/main" xmlns:r="http://schemas.openxmlformats.org/officeDocument/2006/relationships" xmlns:p="http://schemas.openxmlformats.org/presentationml/2006/main">
-  <p:cSld>
-    <p:spTree>
-      <p:nvGrpSpPr>
-        <p:cNvPr id="1" name=""/>
-        <p:cNvGrpSpPr/>
-        <p:nvPr/>
-      </p:nvGrpSpPr>
-      <p:grpSpPr>
-        <a:xfrm>
-          <a:off x="0" y="0"/>
-          <a:ext cx="0" cy="0"/>
-          <a:chOff x="0" y="0"/>
-          <a:chExt cx="0" cy="0"/>
-        </a:xfrm>
-      </p:grpSpPr>
-      <p:sp>
-        <p:nvSpPr>
-          <p:cNvPr id="2" name="Title 1">
-            <a:extLst>
-              <a:ext uri="{FF2B5EF4-FFF2-40B4-BE49-F238E27FC236}">
-                <a16:creationId xmlns:a16="http://schemas.microsoft.com/office/drawing/2014/main" id="{01E53E8A-884D-91E2-41D5-74403C1214DE}"/>
-              </a:ext>
-            </a:extLst>
-          </p:cNvPr>
-          <p:cNvSpPr>
-            <a:spLocks noGrp="1"/>
-          </p:cNvSpPr>
-          <p:nvPr>
-            <p:ph type="title"/>
-          </p:nvPr>
-        </p:nvSpPr>
-        <p:spPr>
-          <a:xfrm>
-            <a:off x="2120587" y="533400"/>
-            <a:ext cx="7950825" cy="1270000"/>
-          </a:xfrm>
-        </p:spPr>
-        <p:txBody>
-          <a:bodyPr/>
-          <a:lstStyle/>
-          <a:p>
-            <a:r>
-              <a:rPr lang="en-US" dirty="0">
-                <a:latin typeface="Garamond" panose="02020404030301010803" pitchFamily="18" charset="0"/>
-              </a:rPr>
-              <a:t>PREDICTING DECISION TREE OUTCOME</a:t>
-            </a:r>
-          </a:p>
-        </p:txBody>
-      </p:sp>
-      <p:pic>
-        <p:nvPicPr>
-          <p:cNvPr id="5" name="Content Placeholder 4">
-            <a:extLst>
-              <a:ext uri="{FF2B5EF4-FFF2-40B4-BE49-F238E27FC236}">
-                <a16:creationId xmlns:a16="http://schemas.microsoft.com/office/drawing/2014/main" id="{4CADB2BA-09E5-D365-8E7F-99E96795A253}"/>
+                <a16:creationId xmlns:a16="http://schemas.microsoft.com/office/drawing/2014/main" id="{E24F51CA-9757-4A8E-2C07-A3329C7302EB}"/>
               </a:ext>
             </a:extLst>
           </p:cNvPr>
           <p:cNvPicPr>
-            <a:picLocks noGrp="1" noChangeAspect="1"/>
+            <a:picLocks noChangeAspect="1"/>
           </p:cNvPicPr>
-          <p:nvPr>
-            <p:ph sz="quarter" idx="13"/>
-          </p:nvPr>
+          <p:nvPr/>
         </p:nvPicPr>
         <p:blipFill>
           <a:blip r:embed="rId2">
@@ -24037,8 +24687,8 @@
         </p:blipFill>
         <p:spPr>
           <a:xfrm>
-            <a:off x="1016000" y="1803400"/>
-            <a:ext cx="10363199" cy="4521200"/>
+            <a:off x="6280399" y="2229657"/>
+            <a:ext cx="5150685" cy="4628343"/>
           </a:xfrm>
           <a:prstGeom prst="rect">
             <a:avLst/>
@@ -24048,7 +24698,7 @@
     </p:spTree>
     <p:extLst>
       <p:ext uri="{BB962C8B-B14F-4D97-AF65-F5344CB8AC3E}">
-        <p14:creationId xmlns:p14="http://schemas.microsoft.com/office/powerpoint/2010/main" val="1766755720"/>
+        <p14:creationId xmlns:p14="http://schemas.microsoft.com/office/powerpoint/2010/main" val="3765150085"/>
       </p:ext>
     </p:extLst>
   </p:cSld>
@@ -24091,9 +24741,16 @@
             <p:ph type="title"/>
           </p:nvPr>
         </p:nvSpPr>
-        <p:spPr/>
+        <p:spPr>
+          <a:xfrm>
+            <a:off x="1100676" y="937554"/>
+            <a:ext cx="9720072" cy="656355"/>
+          </a:xfrm>
+        </p:spPr>
         <p:txBody>
-          <a:bodyPr/>
+          <a:bodyPr>
+            <a:normAutofit fontScale="90000"/>
+          </a:bodyPr>
           <a:lstStyle/>
           <a:p>
             <a:r>
@@ -24107,10 +24764,10 @@
       </p:sp>
       <p:sp>
         <p:nvSpPr>
-          <p:cNvPr id="6" name="Content Placeholder 5">
+          <p:cNvPr id="10" name="Content Placeholder 2">
             <a:extLst>
               <a:ext uri="{FF2B5EF4-FFF2-40B4-BE49-F238E27FC236}">
-                <a16:creationId xmlns:a16="http://schemas.microsoft.com/office/drawing/2014/main" id="{17A3AF69-F997-E06D-4C14-7BBDA0AA1947}"/>
+                <a16:creationId xmlns:a16="http://schemas.microsoft.com/office/drawing/2014/main" id="{B5E7CA25-7F1C-A038-7A91-C673B369BC18}"/>
               </a:ext>
             </a:extLst>
           </p:cNvPr>
@@ -24123,252 +24780,170 @@
         </p:nvSpPr>
         <p:spPr>
           <a:xfrm>
-            <a:off x="913774" y="2006600"/>
-            <a:ext cx="10363826" cy="4419600"/>
+            <a:off x="1024128" y="1939254"/>
+            <a:ext cx="5569620" cy="3424107"/>
           </a:xfrm>
         </p:spPr>
         <p:txBody>
           <a:bodyPr>
-            <a:normAutofit/>
+            <a:normAutofit fontScale="92500" lnSpcReduction="20000"/>
           </a:bodyPr>
           <a:lstStyle/>
           <a:p>
-            <a:pPr marL="0" marR="0" indent="0" algn="just">
+            <a:pPr algn="just"/>
+            <a:r>
+              <a:rPr lang="en-US" dirty="0">
+                <a:latin typeface="Garamond" panose="02020404030301010803" pitchFamily="18" charset="0"/>
+              </a:rPr>
+              <a:t>Three predictive models were developed to forecast forest fires using weather and fuel moisture data. The Decision Tree model proved most effective, detecting 86.5% of all fires, the highest among all models tested.</a:t>
+            </a:r>
+            <a:endParaRPr lang="en-GH" dirty="0">
+              <a:latin typeface="Garamond" panose="02020404030301010803" pitchFamily="18" charset="0"/>
+            </a:endParaRPr>
+          </a:p>
+          <a:p>
+            <a:pPr lvl="0" algn="just"/>
+            <a:r>
+              <a:rPr lang="en-US" b="1" dirty="0">
+                <a:latin typeface="Garamond" panose="02020404030301010803" pitchFamily="18" charset="0"/>
+              </a:rPr>
+              <a:t>KEY FINDINGS:</a:t>
+            </a:r>
+            <a:endParaRPr lang="en-GH" b="1" dirty="0">
+              <a:latin typeface="Garamond" panose="02020404030301010803" pitchFamily="18" charset="0"/>
+            </a:endParaRPr>
+          </a:p>
+          <a:p>
+            <a:pPr lvl="0" algn="just"/>
+            <a:r>
+              <a:rPr lang="en-US" dirty="0">
+                <a:latin typeface="Garamond" panose="02020404030301010803" pitchFamily="18" charset="0"/>
+              </a:rPr>
+              <a:t>The most dangerous conditions for forest fires are:</a:t>
+            </a:r>
+            <a:endParaRPr lang="en-GH" dirty="0">
+              <a:latin typeface="Garamond" panose="02020404030301010803" pitchFamily="18" charset="0"/>
+            </a:endParaRPr>
+          </a:p>
+          <a:p>
+            <a:pPr lvl="0" algn="just"/>
+            <a:r>
+              <a:rPr lang="en-US" dirty="0">
+                <a:latin typeface="Garamond" panose="02020404030301010803" pitchFamily="18" charset="0"/>
+              </a:rPr>
+              <a:t>• High wind speed (strongest predictor)</a:t>
+            </a:r>
+            <a:endParaRPr lang="en-GH" dirty="0">
+              <a:latin typeface="Garamond" panose="02020404030301010803" pitchFamily="18" charset="0"/>
+            </a:endParaRPr>
+          </a:p>
+          <a:p>
+            <a:pPr lvl="0" algn="just"/>
+            <a:r>
+              <a:rPr lang="en-US" dirty="0">
+                <a:latin typeface="Garamond" panose="02020404030301010803" pitchFamily="18" charset="0"/>
+              </a:rPr>
+              <a:t>• Low fuel moisture (FFMC)</a:t>
+            </a:r>
+            <a:endParaRPr lang="en-GH" dirty="0">
+              <a:latin typeface="Garamond" panose="02020404030301010803" pitchFamily="18" charset="0"/>
+            </a:endParaRPr>
+          </a:p>
+          <a:p>
+            <a:pPr lvl="0" algn="just"/>
+            <a:r>
+              <a:rPr lang="en-US" dirty="0">
+                <a:latin typeface="Garamond" panose="02020404030301010803" pitchFamily="18" charset="0"/>
+              </a:rPr>
+              <a:t>• High temperatures</a:t>
+            </a:r>
+            <a:endParaRPr lang="en-GH" dirty="0">
+              <a:latin typeface="Garamond" panose="02020404030301010803" pitchFamily="18" charset="0"/>
+            </a:endParaRPr>
+          </a:p>
+          <a:p>
+            <a:endParaRPr lang="en-GH" dirty="0"/>
+          </a:p>
+        </p:txBody>
+      </p:sp>
+      <p:sp>
+        <p:nvSpPr>
+          <p:cNvPr id="12" name="TextBox 11">
+            <a:extLst>
+              <a:ext uri="{FF2B5EF4-FFF2-40B4-BE49-F238E27FC236}">
+                <a16:creationId xmlns:a16="http://schemas.microsoft.com/office/drawing/2014/main" id="{010D1950-B0FD-7659-08B4-8367FD01ADC9}"/>
+              </a:ext>
+            </a:extLst>
+          </p:cNvPr>
+          <p:cNvSpPr txBox="1"/>
+          <p:nvPr/>
+        </p:nvSpPr>
+        <p:spPr>
+          <a:xfrm>
+            <a:off x="6803471" y="2837835"/>
+            <a:ext cx="5108896" cy="1831207"/>
+          </a:xfrm>
+          <a:prstGeom prst="rect">
+            <a:avLst/>
+          </a:prstGeom>
+          <a:noFill/>
+        </p:spPr>
+        <p:txBody>
+          <a:bodyPr wrap="square">
+            <a:spAutoFit/>
+          </a:bodyPr>
+          <a:lstStyle/>
+          <a:p>
+            <a:pPr>
               <a:lnSpc>
                 <a:spcPct val="107000"/>
               </a:lnSpc>
-              <a:spcBef>
-                <a:spcPts val="0"/>
-              </a:spcBef>
               <a:spcAft>
                 <a:spcPts val="800"/>
               </a:spcAft>
               <a:buNone/>
             </a:pPr>
             <a:r>
-              <a:rPr lang="en-US" sz="1600" b="1" kern="100" dirty="0">
+              <a:rPr lang="en-US" sz="2000" b="1" kern="100" dirty="0">
                 <a:effectLst/>
                 <a:latin typeface="Garamond" panose="02020404030301010803" pitchFamily="18" charset="0"/>
-                <a:ea typeface="Calibri" panose="020F0502020204030204" pitchFamily="34" charset="0"/>
+                <a:ea typeface="DengXian" panose="02010600030101010101" pitchFamily="2" charset="-122"/>
                 <a:cs typeface="Times New Roman" panose="02020603050405020304" pitchFamily="18" charset="0"/>
               </a:rPr>
-              <a:t>Overall Assessment:</a:t>
+              <a:t>CONCLUSION:</a:t>
             </a:r>
-            <a:endParaRPr lang="en-US" sz="1600" kern="100" dirty="0">
+            <a:endParaRPr lang="en-GH" sz="2000" b="1" kern="100" dirty="0">
               <a:effectLst/>
               <a:latin typeface="Garamond" panose="02020404030301010803" pitchFamily="18" charset="0"/>
-              <a:ea typeface="Calibri" panose="020F0502020204030204" pitchFamily="34" charset="0"/>
+              <a:ea typeface="DengXian" panose="02010600030101010101" pitchFamily="2" charset="-122"/>
               <a:cs typeface="Times New Roman" panose="02020603050405020304" pitchFamily="18" charset="0"/>
             </a:endParaRPr>
           </a:p>
           <a:p>
-            <a:pPr marL="342900" marR="0" lvl="0" indent="-342900" algn="just">
+            <a:pPr algn="just">
               <a:lnSpc>
                 <a:spcPct val="107000"/>
               </a:lnSpc>
-              <a:spcBef>
-                <a:spcPts val="0"/>
-              </a:spcBef>
               <a:spcAft>
                 <a:spcPts val="800"/>
               </a:spcAft>
-              <a:buFont typeface="+mj-lt"/>
-              <a:buAutoNum type="arabicPeriod"/>
-              <a:tabLst>
-                <a:tab pos="457200" algn="l"/>
-              </a:tabLst>
+              <a:buNone/>
             </a:pPr>
             <a:r>
-              <a:rPr lang="en-US" sz="1600" b="1" kern="100" dirty="0">
+              <a:rPr lang="en-US" sz="2000" kern="100" dirty="0">
                 <a:effectLst/>
                 <a:latin typeface="Garamond" panose="02020404030301010803" pitchFamily="18" charset="0"/>
-                <a:ea typeface="Calibri" panose="020F0502020204030204" pitchFamily="34" charset="0"/>
+                <a:ea typeface="DengXian" panose="02010600030101010101" pitchFamily="2" charset="-122"/>
                 <a:cs typeface="Times New Roman" panose="02020603050405020304" pitchFamily="18" charset="0"/>
               </a:rPr>
-              <a:t>Model Performance:</a:t>
+              <a:t>Adopting this predictive system can reduce fire damage by alerting authorities before conditions become dangerous, saving forests, property, and lives.</a:t>
             </a:r>
-            <a:endParaRPr lang="en-US" sz="1600" kern="100" dirty="0">
+            <a:endParaRPr lang="en-GH" sz="2000" kern="100" dirty="0">
               <a:effectLst/>
               <a:latin typeface="Garamond" panose="02020404030301010803" pitchFamily="18" charset="0"/>
-              <a:ea typeface="Calibri" panose="020F0502020204030204" pitchFamily="34" charset="0"/>
+              <a:ea typeface="DengXian" panose="02010600030101010101" pitchFamily="2" charset="-122"/>
               <a:cs typeface="Times New Roman" panose="02020603050405020304" pitchFamily="18" charset="0"/>
             </a:endParaRPr>
-          </a:p>
-          <a:p>
-            <a:pPr marL="742950" marR="0" lvl="1" indent="-285750" algn="just">
-              <a:lnSpc>
-                <a:spcPct val="107000"/>
-              </a:lnSpc>
-              <a:spcBef>
-                <a:spcPts val="0"/>
-              </a:spcBef>
-              <a:spcAft>
-                <a:spcPts val="800"/>
-              </a:spcAft>
-              <a:buSzPts val="1000"/>
-              <a:buFont typeface="Courier New" panose="02070309020205020404" pitchFamily="49" charset="0"/>
-              <a:buChar char="o"/>
-              <a:tabLst>
-                <a:tab pos="914400" algn="l"/>
-              </a:tabLst>
-            </a:pPr>
-            <a:r>
-              <a:rPr lang="en-US" sz="1600" kern="100" dirty="0">
-                <a:effectLst/>
-                <a:latin typeface="Garamond" panose="02020404030301010803" pitchFamily="18" charset="0"/>
-                <a:ea typeface="Calibri" panose="020F0502020204030204" pitchFamily="34" charset="0"/>
-                <a:cs typeface="Times New Roman" panose="02020603050405020304" pitchFamily="18" charset="0"/>
-              </a:rPr>
-              <a:t>Both the logistic regression and decision tree models show moderate accuracy, with decision trees performing slightly better.</a:t>
-            </a:r>
-          </a:p>
-          <a:p>
-            <a:pPr marL="742950" marR="0" lvl="1" indent="-285750" algn="just">
-              <a:lnSpc>
-                <a:spcPct val="107000"/>
-              </a:lnSpc>
-              <a:spcBef>
-                <a:spcPts val="0"/>
-              </a:spcBef>
-              <a:spcAft>
-                <a:spcPts val="800"/>
-              </a:spcAft>
-              <a:buSzPts val="1000"/>
-              <a:buFont typeface="Courier New" panose="02070309020205020404" pitchFamily="49" charset="0"/>
-              <a:buChar char="o"/>
-              <a:tabLst>
-                <a:tab pos="914400" algn="l"/>
-              </a:tabLst>
-            </a:pPr>
-            <a:r>
-              <a:rPr lang="en-US" sz="1600" kern="100" dirty="0">
-                <a:effectLst/>
-                <a:latin typeface="Garamond" panose="02020404030301010803" pitchFamily="18" charset="0"/>
-                <a:ea typeface="Calibri" panose="020F0502020204030204" pitchFamily="34" charset="0"/>
-                <a:cs typeface="Times New Roman" panose="02020603050405020304" pitchFamily="18" charset="0"/>
-              </a:rPr>
-              <a:t>Sensitivity is low across both models, highlighting difficulties in correctly identifying fire events.</a:t>
-            </a:r>
-          </a:p>
-          <a:p>
-            <a:pPr marL="742950" marR="0" lvl="1" indent="-285750" algn="just">
-              <a:lnSpc>
-                <a:spcPct val="107000"/>
-              </a:lnSpc>
-              <a:spcBef>
-                <a:spcPts val="0"/>
-              </a:spcBef>
-              <a:spcAft>
-                <a:spcPts val="800"/>
-              </a:spcAft>
-              <a:buSzPts val="1000"/>
-              <a:buFont typeface="Courier New" panose="02070309020205020404" pitchFamily="49" charset="0"/>
-              <a:buChar char="o"/>
-              <a:tabLst>
-                <a:tab pos="914400" algn="l"/>
-              </a:tabLst>
-            </a:pPr>
-            <a:r>
-              <a:rPr lang="en-US" sz="1600" kern="100" dirty="0">
-                <a:effectLst/>
-                <a:latin typeface="Garamond" panose="02020404030301010803" pitchFamily="18" charset="0"/>
-                <a:ea typeface="Calibri" panose="020F0502020204030204" pitchFamily="34" charset="0"/>
-                <a:cs typeface="Times New Roman" panose="02020603050405020304" pitchFamily="18" charset="0"/>
-              </a:rPr>
-              <a:t>Specificity is relatively higher, particularly for the decision tree, indicating a better performance in correctly identifying non-fire events.</a:t>
-            </a:r>
-          </a:p>
-          <a:p>
-            <a:pPr marL="742950" marR="0" lvl="1" indent="-285750" algn="just">
-              <a:lnSpc>
-                <a:spcPct val="107000"/>
-              </a:lnSpc>
-              <a:spcBef>
-                <a:spcPts val="0"/>
-              </a:spcBef>
-              <a:spcAft>
-                <a:spcPts val="800"/>
-              </a:spcAft>
-              <a:buSzPts val="1000"/>
-              <a:buFont typeface="Courier New" panose="02070309020205020404" pitchFamily="49" charset="0"/>
-              <a:buChar char="o"/>
-              <a:tabLst>
-                <a:tab pos="914400" algn="l"/>
-              </a:tabLst>
-            </a:pPr>
-            <a:r>
-              <a:rPr lang="en-US" sz="1600" kern="100" dirty="0">
-                <a:effectLst/>
-                <a:latin typeface="Garamond" panose="02020404030301010803" pitchFamily="18" charset="0"/>
-                <a:ea typeface="Calibri" panose="020F0502020204030204" pitchFamily="34" charset="0"/>
-                <a:cs typeface="Times New Roman" panose="02020603050405020304" pitchFamily="18" charset="0"/>
-              </a:rPr>
-              <a:t>ROC AUC values close to 0.55 for both models suggest limited discriminative power.</a:t>
-            </a:r>
-          </a:p>
-          <a:p>
-            <a:pPr marL="342900" marR="0" lvl="0" indent="-342900" algn="just">
-              <a:lnSpc>
-                <a:spcPct val="107000"/>
-              </a:lnSpc>
-              <a:spcBef>
-                <a:spcPts val="0"/>
-              </a:spcBef>
-              <a:spcAft>
-                <a:spcPts val="800"/>
-              </a:spcAft>
-              <a:buFont typeface="+mj-lt"/>
-              <a:buAutoNum type="arabicPeriod"/>
-              <a:tabLst>
-                <a:tab pos="457200" algn="l"/>
-              </a:tabLst>
-            </a:pPr>
-            <a:r>
-              <a:rPr lang="en-US" sz="1600" b="1" kern="100" dirty="0">
-                <a:effectLst/>
-                <a:latin typeface="Garamond" panose="02020404030301010803" pitchFamily="18" charset="0"/>
-                <a:ea typeface="Calibri" panose="020F0502020204030204" pitchFamily="34" charset="0"/>
-                <a:cs typeface="Times New Roman" panose="02020603050405020304" pitchFamily="18" charset="0"/>
-              </a:rPr>
-              <a:t>Linear Regression:</a:t>
-            </a:r>
-            <a:endParaRPr lang="en-US" sz="1600" kern="100" dirty="0">
-              <a:effectLst/>
-              <a:latin typeface="Garamond" panose="02020404030301010803" pitchFamily="18" charset="0"/>
-              <a:ea typeface="Calibri" panose="020F0502020204030204" pitchFamily="34" charset="0"/>
-              <a:cs typeface="Times New Roman" panose="02020603050405020304" pitchFamily="18" charset="0"/>
-            </a:endParaRPr>
-          </a:p>
-          <a:p>
-            <a:pPr marL="742950" marR="0" lvl="1" indent="-285750" algn="just">
-              <a:lnSpc>
-                <a:spcPct val="107000"/>
-              </a:lnSpc>
-              <a:spcBef>
-                <a:spcPts val="0"/>
-              </a:spcBef>
-              <a:spcAft>
-                <a:spcPts val="800"/>
-              </a:spcAft>
-              <a:buSzPts val="1000"/>
-              <a:buFont typeface="Courier New" panose="02070309020205020404" pitchFamily="49" charset="0"/>
-              <a:buChar char="o"/>
-              <a:tabLst>
-                <a:tab pos="914400" algn="l"/>
-              </a:tabLst>
-            </a:pPr>
-            <a:r>
-              <a:rPr lang="en-US" sz="1600" kern="100" dirty="0">
-                <a:effectLst/>
-                <a:latin typeface="Garamond" panose="02020404030301010803" pitchFamily="18" charset="0"/>
-                <a:ea typeface="Calibri" panose="020F0502020204030204" pitchFamily="34" charset="0"/>
-                <a:cs typeface="Times New Roman" panose="02020603050405020304" pitchFamily="18" charset="0"/>
-              </a:rPr>
-              <a:t>The linear regression model exhibits a moderate level of error (RMSE) and explains only a small proportion of the variance (R-Squared), indicating underfitting.</a:t>
-            </a:r>
-          </a:p>
-          <a:p>
-            <a:endParaRPr lang="en-US" dirty="0"/>
           </a:p>
         </p:txBody>
       </p:sp>

</xml_diff>